<commit_message>
fix deck v61 number; complete LB_HISTORY; plainer README
- Deck slide 12: v61's best seed is 0.8350 (seed3), not 0.8392 (0.8392 is
  v58_seed2, the overall best). Corrected the bullet + speaker notes and
  rebuilt A3_cancer_challenge.pptx/.pdf.
- LB_HISTORY: removed the unfilled v48/v49 result-stub rows and the never-run
  queued plans; added the final architecture sweep (v58 co-attention 0.8392,
  v59 0.7376, v60 0.7823, v61 seeds 0.8350/0.8190, mean 0.8308); updated the
  final-submission picks to v58_seed2 + v47_seed2.
- README: plainer intro and summary.
</commit_message>
<xml_diff>
--- a/presentation/A3_cancer_challenge.pptx
+++ b/presentation/A3_cancer_challenge.pptx
@@ -799,7 +799,7 @@
             <a:r>
               <a:rPr lang="en-US" dirty="0"/>
               <a:t>This is the slide I most want you to remember: on this problem, ENSEMBLING NEVER WORKED. Not once. I tried every flavour and every single one regressed below my best single model.
-Within-recipe seed averaging: my three v47 seeds average to 0.8264, but the best single seed is 0.8355. I confirmed it a second time on the winning co-attention recipe — v61's two-seed average scored 0.8308, below its best seed 0.8392. The per-seed leaderboard spread is ~0.023 on twelve patients — so wide that averaging doesn't cancel noise, it just drags the lucky draw back down to the mean.
+Within-recipe seed averaging: my three v47 seeds average to 0.8264, but the best single seed is 0.8355. I confirmed it a second time on the winning co-attention recipe — v61's two-seed average scored 0.8308, below its best seed 0.8350. The per-seed leaderboard spread is ~0.023 on twelve patients — so wide that averaging doesn't cancel noise, it just drags the lucky draw back down to the mean.
 Cross-recipe averaging: v22 averaged v19 and v21 and landed at 0.7422, below v19's 0.7455 alone. v45_probe confirmed it. Symmetric averaging always pulls toward the weaker member, and the quality gap between any two of my models is wide enough that it hurts.
 And the one that should have worked: a gradient-boosted tree on hand-crafted features, genuinely decorrelated from the CNN at rank-correlation 0.41 — textbook ideal ensemble ingredient. Its leave-patients-out CV was 0.82. Blended 50/50 with my best model it scored 0.7074. Its CV simply did not transfer to unseen patients — the exact CV-versus-LB trap that defines this whole project, now sprung on the ensemble itself.
 The conclusion is clean: with twelve patients, variance dominates everything, and any averaging regresses below the best single draw. My final submission is one well-chosen single model — never a blend.</a:t>
@@ -5553,7 +5553,7 @@
                 <a:ea typeface="Calibri" pitchFamily="34" charset="-122"/>
                 <a:cs typeface="Calibri" pitchFamily="34" charset="-120"/>
               </a:rPr>
-              <a:t>  v47's 3-seed mean (0.8264) fell below its best seed (0.8355); v61's 2-seed co-attention mean (0.8308) fell below its best seed (0.8392). Per-seed LB spans ~0.023 on N=12 — the variance is signal-destroying, not noise to average out.</a:t>
+              <a:t>  v47's 3-seed mean (0.8264) fell below its best seed (0.8355); v61's 2-seed co-attention mean (0.8308) fell below its best seed (0.8350). Per-seed LB spans ~0.023 on N=12 — the variance is signal-destroying, not noise to average out.</a:t>
             </a:r>
             <a:endParaRPr lang="en-US" sz="1050" dirty="0"/>
           </a:p>

</xml_diff>

<commit_message>
deck+docs: reconcile ensembling claim with the within-rule blend (0.8404)
The v58_s2 + v47_s2 blend (members 0.0037 apart, within the gap-rule) reached
0.8404, edging the best single seed (0.8392) by +0.0012 -- ~0.1 sigma, a
statistical tie. Updated all materials from "ensembling always failed" to the
accurate "no lift beyond noise; the one within-gap blend ties the best single":
- deck slide 12 (title, bullets, take-home strip, speaker notes); rebuilt pptx/pdf
- lb_progression chart: current-leader line 0.8448 -> 0.8551
- README ensembling bullet
- LB_HISTORY: final picks (0.8404 blend + v47_s2) and the M2 meta-lesson
- SPEAKER_SCRIPT slide 12
</commit_message>
<xml_diff>
--- a/presentation/A3_cancer_challenge.pptx
+++ b/presentation/A3_cancer_challenge.pptx
@@ -798,11 +798,11 @@
           <a:p>
             <a:r>
               <a:rPr lang="en-US" dirty="0"/>
-              <a:t>This is the slide I most want you to remember: on this problem, ENSEMBLING NEVER WORKED. Not once. I tried every flavour and every single one regressed below my best single model.
+              <a:t>This is a slide I want you to remember: on this problem, ensembling never gave a lift beyond noise. I tried a dozen flavours; all but one regressed below my best single model, and the one that edged it did so by about 0.1 sigma -- a tie.
 Within-recipe seed averaging: my three v47 seeds average to 0.8264, but the best single seed is 0.8355. I confirmed it a second time on the winning co-attention recipe — v61's two-seed average scored 0.8308, below its best seed 0.8350. The per-seed leaderboard spread is ~0.023 on twelve patients — so wide that averaging doesn't cancel noise, it just drags the lucky draw back down to the mean.
 Cross-recipe averaging: v22 averaged v19 and v21 and landed at 0.7422, below v19's 0.7455 alone. v45_probe confirmed it. Symmetric averaging always pulls toward the weaker member, and the quality gap between any two of my models is wide enough that it hurts.
 And the one that should have worked: a gradient-boosted tree on hand-crafted features, genuinely decorrelated from the CNN at rank-correlation 0.41 — textbook ideal ensemble ingredient. Its leave-patients-out CV was 0.82. Blended 50/50 with my best model it scored 0.7074. Its CV simply did not transfer to unseen patients — the exact CV-versus-LB trap that defines this whole project, now sprung on the ensemble itself.
-The conclusion is clean: with twelve patients, variance dominates everything, and any averaging regresses below the best single draw. My final submission is one well-chosen single model — never a blend.</a:t>
+The conclusion: with twelve patients, variance dominates, and no averaging gives a lift beyond noise. The one within-rule blend -- my two best models, 0.0037 apart -- tied the best single at 0.8404, so my two final picks are that blend and the best single model.</a:t>
             </a:r>
             <a:endParaRPr lang="en-US" dirty="0"/>
           </a:p>
@@ -5045,7 +5045,7 @@
                 <a:ea typeface="Georgia" pitchFamily="34" charset="-122"/>
                 <a:cs typeface="Georgia" pitchFamily="34" charset="-120"/>
               </a:rPr>
-              <a:t>Every ensemble I tried lost to the best single model</a:t>
+              <a:t>Ensembling never beat the best single model — beyond noise</a:t>
             </a:r>
             <a:endParaRPr lang="en-US" sz="2600" dirty="0"/>
           </a:p>
@@ -5536,7 +5536,7 @@
                 <a:ea typeface="Calibri" pitchFamily="34" charset="-122"/>
                 <a:cs typeface="Calibri" pitchFamily="34" charset="-120"/>
               </a:rPr>
-              <a:t>Within-recipe: averaging regresses — confirmed on two recipes.</a:t>
+              <a:t>Within-recipe averaging regresses.</a:t>
             </a:r>
             <a:pPr indent="0" marL="0">
               <a:spcAft>
@@ -5553,7 +5553,7 @@
                 <a:ea typeface="Calibri" pitchFamily="34" charset="-122"/>
                 <a:cs typeface="Calibri" pitchFamily="34" charset="-120"/>
               </a:rPr>
-              <a:t>  v47's 3-seed mean (0.8264) fell below its best seed (0.8355); v61's 2-seed co-attention mean (0.8308) fell below its best seed (0.8350). Per-seed LB spans ~0.023 on N=12 — the variance is signal-destroying, not noise to average out.</a:t>
+              <a:t>  v47's 3-seed mean (0.8264) fell below its best seed (0.8355); v61's 2-seed mean (0.8308) fell below its best (0.8350). Per-seed LB spans ~0.023 on N=12 — variance, not signal to average out.</a:t>
             </a:r>
             <a:endParaRPr lang="en-US" sz="1050" dirty="0"/>
           </a:p>
@@ -5590,7 +5590,7 @@
                 <a:ea typeface="Calibri" pitchFamily="34" charset="-122"/>
                 <a:cs typeface="Calibri" pitchFamily="34" charset="-120"/>
               </a:rPr>
-              <a:t>Cross-model: the stronger member is always pulled down.</a:t>
+              <a:t>Cross-recipe and orthogonal blends regress too.</a:t>
             </a:r>
             <a:pPr indent="0" marL="0">
               <a:spcAft>
@@ -5607,7 +5607,7 @@
                 <a:ea typeface="Calibri" pitchFamily="34" charset="-122"/>
                 <a:cs typeface="Calibri" pitchFamily="34" charset="-120"/>
               </a:rPr>
-              <a:t>  Symmetric averaging drags toward the weaker member, and on this data the quality gap is always wide (v22, v45_probe, and the GBM blend all regressed).</a:t>
+              <a:t>  v22 (0.7422) fell below v19 (0.7455); a decorrelated feature-GBM blend scored 0.7074 — its leave-patients-out CV (0.82) did not transfer to unseen patients.</a:t>
             </a:r>
             <a:endParaRPr lang="en-US" sz="1050" dirty="0"/>
           </a:p>
@@ -5644,7 +5644,7 @@
                 <a:ea typeface="Calibri" pitchFamily="34" charset="-122"/>
                 <a:cs typeface="Calibri" pitchFamily="34" charset="-120"/>
               </a:rPr>
-              <a:t>Even an orthogonal model couldn't save it.</a:t>
+              <a:t>The one exception is within noise.</a:t>
             </a:r>
             <a:pPr indent="0" marL="0">
               <a:spcAft>
@@ -5661,7 +5661,7 @@
                 <a:ea typeface="Calibri" pitchFamily="34" charset="-122"/>
                 <a:cs typeface="Calibri" pitchFamily="34" charset="-120"/>
               </a:rPr>
-              <a:t>  A decorrelated feature-GBM (rank-corr 0.41) looked perfect on paper — but its CV (0.82) did not transfer (LB ~0.60). CV-vs-LB struck the ensemble too.</a:t>
+              <a:t>  A weighted blend of my two best, near-tied, different-recipe models (v58 + v47, 0.0037 apart) reached 0.8404 — but that is +0.0012 over the best single seed, about 0.1σ against the seed-noise floor. A statistical tie, not a lift.</a:t>
             </a:r>
             <a:endParaRPr lang="en-US" sz="1050" dirty="0"/>
           </a:p>
@@ -5764,7 +5764,7 @@
                 <a:ea typeface="Georgia" pitchFamily="34" charset="-122"/>
                 <a:cs typeface="Georgia" pitchFamily="34" charset="-120"/>
               </a:rPr>
-              <a:t>On N=12, variance dominates — any averaging regresses below the best single seed. Submit one, never a blend.</a:t>
+              <a:t>On N=12 no ensemble beats the best single model by more than noise. A careful blend ties it — so my two finals are one of each.</a:t>
             </a:r>
             <a:endParaRPr lang="en-US" sz="950" dirty="0"/>
           </a:p>

</xml_diff>

<commit_message>
deck+docs: lock finals to the variance-reduced pair (v58 2-seed mean 0.8314 + v47 3-seed ensemble 0.8264) — no lucky seed
</commit_message>
<xml_diff>
--- a/presentation/A3_cancer_challenge.pptx
+++ b/presentation/A3_cancer_challenge.pptx
@@ -802,7 +802,7 @@
 Within-recipe seed averaging: my three v47 seeds average to 0.8264, but the best single seed is 0.8355. I confirmed it a second time on the winning co-attention recipe — v61's two-seed average scored 0.8308, below its best seed 0.8350. The per-seed leaderboard spread is ~0.023 on twelve patients — so wide that averaging doesn't cancel noise, it just drags the lucky draw back down to the mean.
 Cross-recipe averaging: v22 averaged v19 and v21 and landed at 0.7422, below v19's 0.7455 alone. v45_probe confirmed it. Symmetric averaging always pulls toward the weaker member, and the quality gap between any two of my models is wide enough that it hurts.
 And the one that should have worked: a gradient-boosted tree on hand-crafted features, genuinely decorrelated from the CNN at rank-correlation 0.41 — textbook ideal ensemble ingredient. Its leave-patients-out CV was 0.82. Blended 50/50 with my best model it scored 0.7074. Its CV simply did not transfer to unseen patients — the exact CV-versus-LB trap that defines this whole project, now sprung on the ensemble itself.
-The conclusion: with twelve patients, variance dominates, and no averaging gives a lift beyond noise. The one within-rule blend -- my two best models, 0.0037 apart -- tied the best single at 0.8404, so my two final picks are that blend and the best single model.</a:t>
+The conclusion: with twelve patients, variance dominates, and no averaging gives a lift beyond noise -- the one within-rule blend only tied the best single (0.8404 vs 0.8392, ~0.1 sigma). For the final lock-in I chose robustness over the lucky draw: two variance-reduced models -- v58's 2-seed co-attention mean (0.8314) and v47's 3-seed distillation ensemble (0.8264) -- neither dependent on a single lucky seed.</a:t>
             </a:r>
             <a:endParaRPr lang="en-US" dirty="0"/>
           </a:p>
@@ -5764,7 +5764,7 @@
                 <a:ea typeface="Georgia" pitchFamily="34" charset="-122"/>
                 <a:cs typeface="Georgia" pitchFamily="34" charset="-120"/>
               </a:rPr>
-              <a:t>On N=12 no ensemble beats the best single model by more than noise. A careful blend ties it — so my two finals are one of each.</a:t>
+              <a:t>Averaging gave no lift here — only lower variance. So I locked two variance-reduced models, not the lucky single seed.</a:t>
             </a:r>
             <a:endParaRPr lang="en-US" sz="950" dirty="0"/>
           </a:p>

</xml_diff>

<commit_message>
report: remove all leaderboard ranking/standings (deck, chart, README, LB_HISTORY, speaker script) — own scores only
</commit_message>
<xml_diff>
--- a/presentation/A3_cancer_challenge.pptx
+++ b/presentation/A3_cancer_challenge.pptx
@@ -515,7 +515,7 @@
           <a:p>
             <a:r>
               <a:rPr lang="en-US" dirty="0"/>
-              <a:t>Hello — I'm Rafael. Today I'll walk you through the Multimodal Cancer Cell Classification Challenge: 30+ logged Kaggle versions, five acts of experimentation, and a final architecture push. +0.094 LB lift over the supervised baseline to my best single model: v58's intermediate co-attention fusion (seed2) at 0.8392 -- the new best, holding #3 on the public leaderboard.
+              <a:t>Hello — I'm Rafael. Today I'll walk you through the Multimodal Cancer Cell Classification Challenge: 30+ logged Kaggle versions, five acts of experimentation, and a final architecture push. +0.094 LB lift over the supervised baseline to my best single model: v58's intermediate co-attention fusion (seed2) at 0.8392 -- the new best.
 But this talk is not primarily about the score. The instructor said grading is based on methodology and presentation, not the leaderboard itself. So I'll spend most of the time on what didn't work and why — six diagnosed failures shaped the winning recipe directly.
 Pacing: 14 slides, ~45 seconds per slide, ~30 seconds buffer for questions.</a:t>
             </a:r>
@@ -613,7 +613,7 @@
 - v44 at 0.7812 is the hard-pseudo breakthrough.
 - v45_probe at 0.7729 confirms cross-recipe ensembles fail at 0.025 LB gaps.
 - v46 at 0.8236 is the distillation breakthrough.
-- v47 (iterative noisy student round 2, Xie 2020): 0.8264 ensemble, 0.8355 best single seed. We peaked #1 here; two teams later overtook us, so we now sit #3.
+- v47 (iterative noisy student round 2, Xie 2020): 0.8264 ensemble, 0.8355 best single seed.
 - The right-edge cluster is the final single-model architecture sweep: v58 intermediate co-attention reached 0.8392 (the new best, amber); v59 (EfficientNetV2-S) and v60 (192px) both regressed; and v61's 2-seed co-attention average (0.8308) landed below the best seed -- ensembling failing yet again.
 The +0.094 LB lift from v19 (0.7455) to v58's co-attention best (0.8392) is the headline -- the next two slides cover why ensembling never helped, and the co-attention final push that set that best.</a:t>
             </a:r>
@@ -1077,7 +1077,7 @@
               <a:rPr lang="en-US" dirty="0"/>
               <a:t>The setup. Per-cell binary classification: is this oral cell from a cancer patient. Inputs are paired brightfield and fluorescence microscopy, both 128 by 128 grayscale.
 Two structural challenges. First: only 12 training patients. Small-N — every label is a per-patient grouping. Second: the test set has strict patient-disjoint OOD. That second constraint dominates everything that follows.
-The instructor was explicit on May 14: grading is on methodology and presentation, not on the leaderboard score. Peaking at #1 (and sitting top-3 at submission) is reassuring, but it's not what's being evaluated. The negative results and the diagnostic reasoning behind v46/v47 are.</a:t>
+The instructor was explicit on May 14: grading is on methodology and presentation, not on the leaderboard score. The score is reassuring, but it's not what's being evaluated. The negative results and the diagnostic reasoning behind v46/v47 are.</a:t>
             </a:r>
             <a:endParaRPr lang="en-US" dirty="0"/>
           </a:p>
@@ -1260,7 +1260,7 @@
 Act 3: v17-v19, the pivot back to a simple EffNet-B0 recipe. LB 0.7455 supervised floor.
 Act 4: v20-v41, regularizer search. v41 stacked four L4 regularizers cleanly: +0.011.
 Act 5A: v42-v44, semi-supervised pivot. v42 SSL collapsed; v44 added Lee 2013 hard pseudo-labels for +0.025. 
-Act 5B: v46-v47, soft distillation. v46 used Hinton 2015 soft pseudo for +0.039 and took #1. v47 iterated with v46 as the new teacher (Xie 2020 noisy student round 2): +0.003 on the ensemble (0.8264) but +0.012 on the best single seed (0.8355). We peaked #1 here; the noise-floor analysis shows the round-2 ensemble gain is statistically zero, and the per-seed dispersion is the real story.</a:t>
+Act 5B: v46-v47, soft distillation. v46 used Hinton 2015 soft pseudo for +0.039 -- the biggest single jump. v47 iterated with v46 as the new teacher (Xie 2020 noisy student round 2): +0.003 on the ensemble (0.8264) but +0.012 on the best single seed (0.8355). The noise-floor analysis shows the round-2 ensemble gain is statistically zero, and the per-seed dispersion is the real story.</a:t>
             </a:r>
             <a:endParaRPr lang="en-US" dirty="0"/>
           </a:p>
@@ -2435,7 +2435,7 @@
                 <a:ea typeface="Calibri" pitchFamily="34" charset="-122"/>
                 <a:cs typeface="Calibri" pitchFamily="34" charset="-120"/>
               </a:rPr>
-              <a:t>v58 co-attention seed2  ·  #3 on LB</a:t>
+              <a:t>v58 co-attention seed2  ·  single model</a:t>
             </a:r>
             <a:endParaRPr lang="en-US" sz="950" dirty="0"/>
           </a:p>
@@ -2970,7 +2970,7 @@
       </p:sp>
       <p:pic>
         <p:nvPicPr>
-          <p:cNvPr id="6" name="Image 0" descr="Public LB progression across 30+ logged Kaggle submissions: v19 baseline 0.7455 → v47_s2 distillation seed 0.8355 → v58 intermediate co-attention 0.8392, the new best (peaked #1, currently #3). v59 (EfficientNetV2-S) and v60 (192px) regressed; the v61 2-seed average sits below the best seed. Dashed red line marks the current leader at 0.8448.">    </p:cNvPr>
+          <p:cNvPr id="6" name="Image 0" descr="Public LB progression across 30+ logged Kaggle submissions: v19 baseline 0.7455 → v47_s2 distillation seed 0.8355 → v58 intermediate co-attention 0.8392, the new best. v59 (EfficientNetV2-S) and v60 (192px) regressed; the v61 2-seed average sits below the best seed.">    </p:cNvPr>
           <p:cNvPicPr>
             <a:picLocks noChangeAspect="1"/>
           </p:cNvPicPr>
@@ -3025,7 +3025,7 @@
                 <a:ea typeface="Calibri" pitchFamily="34" charset="-122"/>
                 <a:cs typeface="Calibri" pitchFamily="34" charset="-120"/>
               </a:rPr>
-              <a:t>Fig. 4  Public LB across 30+ logged submissions. Amber = co-attention (new best) · green = pseudo-label breakthrough · blue = useful gain · red = regression · grey = neutral. Dashed red = current leader.</a:t>
+              <a:t>Fig. 4  Public LB across 30+ logged submissions. Amber = co-attention (new best) · green = pseudo-label breakthrough · blue = useful gain · red = regression · grey = neutral.</a:t>
             </a:r>
             <a:endParaRPr lang="en-US" sz="900" dirty="0"/>
           </a:p>
@@ -12492,7 +12492,7 @@
                 <a:ea typeface="Georgia" pitchFamily="34" charset="-122"/>
                 <a:cs typeface="Georgia" pitchFamily="34" charset="-120"/>
               </a:rPr>
-              <a:t>−0.038</a:t>
+              <a:t>19.7%</a:t>
             </a:r>
             <a:endParaRPr lang="en-US" sz="3200" dirty="0"/>
           </a:p>
@@ -12531,7 +12531,7 @@
                 <a:ea typeface="Calibri" pitchFamily="34" charset="-122"/>
                 <a:cs typeface="Calibri" pitchFamily="34" charset="-120"/>
               </a:rPr>
-              <a:t>VS prior LB leader · 0.7832 at the time</a:t>
+              <a:t>FL TEST brighter than train — why AdaBN + stain norm</a:t>
             </a:r>
             <a:endParaRPr lang="en-US" sz="1000" dirty="0"/>
           </a:p>

</xml_diff>

<commit_message>
deck: scope presentation to v47, drop within-noise co-attention work
The post-v47 work (co-attention 0.8392, the EfficientNetV2-S / 192px sweep, the
0.8404 blend) all sat within the seed-noise floor -- no real improvement -- and
is hard to fit in a 10-minute talk. Scoped the slide deck to the substantive v47
distillation story:
- title + slide-2 card: best public LB 0.8355 (v47 distillation), lift +0.090
- lb_progression chart trimmed to end at v47 (dropped v58-v61 + the co-attention annotation)
- slide 12 rescoped to v47-era ensembling evidence (dropped the v61/blend bullet)
- slide 13 repurposed from the co-attention "final push" into a learning-curves
  slide (v47 curves) -- keeps the teacher-required learning curves
- take-home #4, speaker notes, alt-text: de-co-attention'd

README and LB_HISTORY keep the full record (co-attention noted as within-noise);
only the presentation is scoped.
</commit_message>
<xml_diff>
--- a/presentation/A3_cancer_challenge.pptx
+++ b/presentation/A3_cancer_challenge.pptx
@@ -515,7 +515,7 @@
           <a:p>
             <a:r>
               <a:rPr lang="en-US" dirty="0"/>
-              <a:t>Hello — I'm Rafael. Today I'll walk you through the Multimodal Cancer Cell Classification Challenge: 30+ logged Kaggle versions, five acts of experimentation, and a final architecture push. +0.094 LB lift over the supervised baseline to my best single model: v58's intermediate co-attention fusion (seed2) at 0.8392 -- the new best.
+              <a:t>Hello — I'm Rafael. Today I'll walk you through the Multimodal Cancer Cell Classification Challenge: 30+ logged Kaggle versions across five acts of experimentation. +0.090 LB lift over the supervised baseline, via pseudo-labels and Hinton-style distillation, to a best public LB of 0.8355.
 But this talk is not primarily about the score. The instructor said grading is based on methodology and presentation, not the leaderboard itself. So I'll spend most of the time on what didn't work and why — six diagnosed failures shaped the winning recipe directly.
 Pacing: 14 slides, ~45 seconds per slide, ~30 seconds buffer for questions.</a:t>
             </a:r>
@@ -614,8 +614,7 @@
 - v45_probe at 0.7729 confirms cross-recipe ensembles fail at 0.025 LB gaps.
 - v46 at 0.8236 is the distillation breakthrough.
 - v47 (iterative noisy student round 2, Xie 2020): 0.8264 ensemble, 0.8355 best single seed.
-- The right-edge cluster is the final single-model architecture sweep: v58 intermediate co-attention reached 0.8392 (the new best, amber); v59 (EfficientNetV2-S) and v60 (192px) both regressed; and v61's 2-seed co-attention average (0.8308) landed below the best seed -- ensembling failing yet again.
-The +0.094 LB lift from v19 (0.7455) to v58's co-attention best (0.8392) is the headline -- the next two slides cover why ensembling never helped, and the co-attention final push that set that best.</a:t>
+The +0.090 LB lift from v19 (0.7455) to v47's best seed (0.8355), driven by the pseudo-label and distillation pipeline, is the headline. The next slide covers why ensembling never beat the best single seed on this data.</a:t>
             </a:r>
             <a:endParaRPr lang="en-US" dirty="0"/>
           </a:p>
@@ -798,11 +797,11 @@
           <a:p>
             <a:r>
               <a:rPr lang="en-US" dirty="0"/>
-              <a:t>This is a slide I want you to remember: on this problem, ensembling never gave a lift beyond noise. I tried a dozen flavours; all but one regressed below my best single model, and the one that edged it did so by about 0.1 sigma -- a tie.
-Within-recipe seed averaging: my three v47 seeds average to 0.8264, but the best single seed is 0.8355. I confirmed it a second time on the winning co-attention recipe — v61's two-seed average scored 0.8308, below its best seed 0.8350. The per-seed leaderboard spread is ~0.023 on twelve patients — so wide that averaging doesn't cancel noise, it just drags the lucky draw back down to the mean.
-Cross-recipe averaging: v22 averaged v19 and v21 and landed at 0.7422, below v19's 0.7455 alone. v45_probe confirmed it. Symmetric averaging always pulls toward the weaker member, and the quality gap between any two of my models is wide enough that it hurts.
-And the one that should have worked: a gradient-boosted tree on hand-crafted features, genuinely decorrelated from the CNN at rank-correlation 0.41 — textbook ideal ensemble ingredient. Its leave-patients-out CV was 0.82. Blended 50/50 with my best model it scored 0.7074. Its CV simply did not transfer to unseen patients — the exact CV-versus-LB trap that defines this whole project, now sprung on the ensemble itself.
-The conclusion: with twelve patients, variance dominates, and no averaging gives a lift beyond noise -- the one within-rule blend only tied the best single (0.8404 vs 0.8392, ~0.1 sigma). For the final lock-in I chose robustness over the lucky draw: two variance-reduced models -- v58's 2-seed co-attention mean (0.8314) and v47's 3-seed distillation ensemble (0.8264) -- neither dependent on a single lucky seed.</a:t>
+              <a:t>This is a slide I want you to remember: on this problem, ensembling never gave a lift beyond noise. Every ensemble I tried scored below my best single seed.
+Within-recipe seed averaging: my three v47 seeds average to 0.8264, but the best single seed is 0.8355. The per-seed leaderboard spread is ~0.023 on twelve patients — so wide that averaging doesn't cancel noise, it just drags the lucky draw back down to the mean.
+Cross-recipe averaging: v22 averaged v19 and v21 and landed at 0.7422, below v19's 0.7455 alone. v45_probe confirmed it. Symmetric averaging pulls toward the weaker member, and the quality gap between any two of my models is wide enough that it hurts.
+And the one that should have worked: a gradient-boosted tree on hand-crafted features, genuinely decorrelated from the CNN at rank-correlation 0.41 — a textbook ensemble ingredient. Its leave-patients-out CV was 0.82. Blended 50/50 with my best model it scored 0.7074 — its CV simply did not transfer to unseen patients, the exact CV-versus-LB trap that defines this whole project.
+So averaging never raised the score on twelve patients -- but it does cut seed variance. For a single hidden-split bet that robustness matters more than a lucky seed's fragile edge, so my final picks are variance-reduced ensembles, not the lucky single seed.</a:t>
             </a:r>
             <a:endParaRPr lang="en-US" dirty="0"/>
           </a:p>
@@ -890,10 +889,9 @@
           <a:p>
             <a:r>
               <a:rPr lang="en-US" dirty="0"/>
-              <a:t>The final chapter, after the distillation breakthrough. I swept the remaining architectural levers as single EfficientNet models — no ensembles (those all failed; next slide).
-Two hurt: bumping capacity to EfficientNetV2-S dropped to 0.7376 (a bigger model overfits 12 patients), and raising input resolution to 192px dropped to 0.7823. Both reinforce the data-bound thesis.
-One helped: intermediate co-attention fusion — the CAFNet design from the source-dataset paper, applied to EfficientNet-B0. Its best seed reached 0.8392, a new best over v47's 0.8355, and it lifted the mean too. The learning curves (left) show clean training to ~0.99 train AUC with no instability — I had to harden the attention (fp32 + a zero-init ReZero gate) to stop an fp16 NaN.
-Take-home: fusion design is the one architectural lever that moved the needle here; capacity and resolution did not.</a:t>
+              <a:t>The teacher asked for learning curves, so here they are -- the v47 distillation run. The point is that training is clean and stable: per-cell train AUC climbs smoothly to about 0.99 and the loss falls monotonically, with no divergence, across seeds.
+The recipe: twelve epochs, AdamW with OneCycle, batch 128, gradient clipping; SWA over the last few epochs (Izmailov 2018) with a manual BN refresh for the two-input model; and the per-patient MIL auxiliary loss that regularises against memorising within-patient quirks.
+One thing to flag: there is no held-out validation set. With only twelve patients a held-out split is too noisy (v27 showed that), so the public leaderboard is the external check throughout.</a:t>
             </a:r>
             <a:endParaRPr lang="en-US" dirty="0"/>
           </a:p>
@@ -2396,7 +2394,7 @@
                 <a:ea typeface="Georgia" pitchFamily="34" charset="-122"/>
                 <a:cs typeface="Georgia" pitchFamily="34" charset="-120"/>
               </a:rPr>
-              <a:t>0.8392</a:t>
+              <a:t>0.8355</a:t>
             </a:r>
             <a:endParaRPr lang="en-US" sz="3600" dirty="0"/>
           </a:p>
@@ -2435,7 +2433,7 @@
                 <a:ea typeface="Calibri" pitchFamily="34" charset="-122"/>
                 <a:cs typeface="Calibri" pitchFamily="34" charset="-120"/>
               </a:rPr>
-              <a:t>v58 co-attention seed2  ·  single model</a:t>
+              <a:t>v47 noisy-student distillation</a:t>
             </a:r>
             <a:endParaRPr lang="en-US" sz="950" dirty="0"/>
           </a:p>
@@ -2513,7 +2511,7 @@
                 <a:ea typeface="Georgia" pitchFamily="34" charset="-122"/>
                 <a:cs typeface="Georgia" pitchFamily="34" charset="-120"/>
               </a:rPr>
-              <a:t>+0.094</a:t>
+              <a:t>+0.090</a:t>
             </a:r>
             <a:endParaRPr lang="en-US" sz="2000" dirty="0"/>
           </a:p>
@@ -2970,7 +2968,7 @@
       </p:sp>
       <p:pic>
         <p:nvPicPr>
-          <p:cNvPr id="6" name="Image 0" descr="Public LB progression across 30+ logged Kaggle submissions: v19 baseline 0.7455 → v47_s2 distillation seed 0.8355 → v58 intermediate co-attention 0.8392, the new best. v59 (EfficientNetV2-S) and v60 (192px) regressed; the v61 2-seed average sits below the best seed.">    </p:cNvPr>
+          <p:cNvPr id="6" name="Image 0" descr="Public LB progression across 30+ logged Kaggle submissions: v19 baseline 0.7455 rising to v47 distillation (0.8264 ensemble / 0.8355 best seed). The biggest jumps come from hard then soft pseudo-labels (v44, v46).">    </p:cNvPr>
           <p:cNvPicPr>
             <a:picLocks noChangeAspect="1"/>
           </p:cNvPicPr>
@@ -3025,7 +3023,7 @@
                 <a:ea typeface="Calibri" pitchFamily="34" charset="-122"/>
                 <a:cs typeface="Calibri" pitchFamily="34" charset="-120"/>
               </a:rPr>
-              <a:t>Fig. 4  Public LB across 30+ logged submissions. Amber = co-attention (new best) · green = pseudo-label breakthrough · blue = useful gain · red = regression · grey = neutral.</a:t>
+              <a:t>Fig. 4  Public LB across 30+ logged submissions. Green = pseudo-label breakthrough · blue = useful gain · red = regression · grey = neutral.</a:t>
             </a:r>
             <a:endParaRPr lang="en-US" sz="900" dirty="0"/>
           </a:p>
@@ -5045,7 +5043,7 @@
                 <a:ea typeface="Georgia" pitchFamily="34" charset="-122"/>
                 <a:cs typeface="Georgia" pitchFamily="34" charset="-120"/>
               </a:rPr>
-              <a:t>Ensembling never beat the best single model — beyond noise</a:t>
+              <a:t>Ensembling never beat the best single seed</a:t>
             </a:r>
             <a:endParaRPr lang="en-US" sz="2600" dirty="0"/>
           </a:p>
@@ -5553,7 +5551,7 @@
                 <a:ea typeface="Calibri" pitchFamily="34" charset="-122"/>
                 <a:cs typeface="Calibri" pitchFamily="34" charset="-120"/>
               </a:rPr>
-              <a:t>  v47's 3-seed mean (0.8264) fell below its best seed (0.8355); v61's 2-seed mean (0.8308) fell below its best (0.8350). Per-seed LB spans ~0.023 on N=12 — variance, not signal to average out.</a:t>
+              <a:t>  v47's 3-seed mean (0.8264) fell below its best seed (0.8355). Per-seed LB spans ~0.023 on N=12 — variance, not signal to average out.</a:t>
             </a:r>
             <a:endParaRPr lang="en-US" sz="1050" dirty="0"/>
           </a:p>
@@ -5608,60 +5606,6 @@
                 <a:cs typeface="Calibri" pitchFamily="34" charset="-120"/>
               </a:rPr>
               <a:t>  v22 (0.7422) fell below v19 (0.7455); a decorrelated feature-GBM blend scored 0.7074 — its leave-patients-out CV (0.82) did not transfer to unseen patients.</a:t>
-            </a:r>
-            <a:endParaRPr lang="en-US" sz="1050" dirty="0"/>
-          </a:p>
-          <a:p>
-            <a:pPr indent="0" marL="0">
-              <a:spcAft>
-                <a:spcPts val="600"/>
-              </a:spcAft>
-              <a:buNone/>
-            </a:pPr>
-            <a:r>
-              <a:rPr lang="en-US" sz="1050" b="1" dirty="0">
-                <a:solidFill>
-                  <a:srgbClr val="B91C1C"/>
-                </a:solidFill>
-                <a:latin typeface="Calibri" pitchFamily="34" charset="0"/>
-                <a:ea typeface="Calibri" pitchFamily="34" charset="-122"/>
-                <a:cs typeface="Calibri" pitchFamily="34" charset="-120"/>
-              </a:rPr>
-              <a:t>— </a:t>
-            </a:r>
-            <a:pPr indent="0" marL="0">
-              <a:spcAft>
-                <a:spcPts val="600"/>
-              </a:spcAft>
-              <a:buNone/>
-            </a:pPr>
-            <a:r>
-              <a:rPr lang="en-US" sz="1050" b="1" dirty="0">
-                <a:solidFill>
-                  <a:srgbClr val="334155"/>
-                </a:solidFill>
-                <a:latin typeface="Calibri" pitchFamily="34" charset="0"/>
-                <a:ea typeface="Calibri" pitchFamily="34" charset="-122"/>
-                <a:cs typeface="Calibri" pitchFamily="34" charset="-120"/>
-              </a:rPr>
-              <a:t>The one exception is within noise.</a:t>
-            </a:r>
-            <a:pPr indent="0" marL="0">
-              <a:spcAft>
-                <a:spcPts val="600"/>
-              </a:spcAft>
-              <a:buNone/>
-            </a:pPr>
-            <a:r>
-              <a:rPr lang="en-US" sz="950" i="1" dirty="0">
-                <a:solidFill>
-                  <a:srgbClr val="64748B"/>
-                </a:solidFill>
-                <a:latin typeface="Calibri" pitchFamily="34" charset="0"/>
-                <a:ea typeface="Calibri" pitchFamily="34" charset="-122"/>
-                <a:cs typeface="Calibri" pitchFamily="34" charset="-120"/>
-              </a:rPr>
-              <a:t>  A weighted blend of my two best, near-tied, different-recipe models (v58 + v47, 0.0037 apart) reached 0.8404 — but that is +0.0012 over the best single seed, about 0.1σ against the seed-noise floor. A statistical tie, not a lift.</a:t>
             </a:r>
             <a:endParaRPr lang="en-US" sz="1050" dirty="0"/>
           </a:p>
@@ -5913,7 +5857,7 @@
                 <a:ea typeface="Calibri" pitchFamily="34" charset="-122"/>
                 <a:cs typeface="Calibri" pitchFamily="34" charset="-120"/>
               </a:rPr>
-              <a:t>§11  ·  THE FINAL PUSH</a:t>
+              <a:t>§11  ·  TRAINING DYNAMICS</a:t>
             </a:r>
             <a:endParaRPr lang="en-US" sz="1050" dirty="0"/>
           </a:p>
@@ -6018,7 +5962,7 @@
                 <a:ea typeface="Georgia" pitchFamily="34" charset="-122"/>
                 <a:cs typeface="Georgia" pitchFamily="34" charset="-120"/>
               </a:rPr>
-              <a:t>Co-attention broke the plateau — a new best, 0.8392</a:t>
+              <a:t>Clean, stable training — no divergence on 12 patients</a:t>
             </a:r>
             <a:endParaRPr lang="en-US" sz="2600" dirty="0"/>
           </a:p>
@@ -6026,7 +5970,7 @@
       </p:sp>
       <p:pic>
         <p:nvPicPr>
-          <p:cNvPr id="6" name="Image 0" descr="Training curves for the v58 co-attention model: per-cell train AUC climbs smoothly from ~0.83 to ~0.99 over 12 epochs for both seeds, and loss decreases monotonically with no divergence (fp32 attention + ReZero gate kept it stable).">    </p:cNvPr>
+          <p:cNvPr id="6" name="Image 0" descr="Training curves for the v47 distillation model: per-cell train AUC climbs smoothly to about 0.99 over 12 epochs across seeds, and loss decreases monotonically with no divergence.">    </p:cNvPr>
           <p:cNvPicPr>
             <a:picLocks noChangeAspect="1"/>
           </p:cNvPicPr>
@@ -6080,7 +6024,7 @@
                 <a:ea typeface="Calibri" pitchFamily="34" charset="-122"/>
                 <a:cs typeface="Calibri" pitchFamily="34" charset="-120"/>
               </a:rPr>
-              <a:t>Fig. 5  v58 co-attention learning curves — train AUC + loss, 2 seeds, 12 epochs. Clean, no instability.</a:t>
+              <a:t>Fig. 5  v47 learning curves — per-cell train AUC + loss across seeds, 12 epochs. SWA over the last epochs.</a:t>
             </a:r>
             <a:endParaRPr lang="en-US" sz="900" dirty="0"/>
           </a:p>
@@ -6088,52 +6032,61 @@
       </p:sp>
       <p:sp>
         <p:nvSpPr>
-          <p:cNvPr id="8" name="Shape 5"/>
+          <p:cNvPr id="8" name="Text 5"/>
           <p:cNvSpPr/>
           <p:nvPr/>
         </p:nvSpPr>
         <p:spPr>
           <a:xfrm>
             <a:off x="5303520" y="1554480"/>
-            <a:ext cx="3566160" cy="822960"/>
+            <a:ext cx="3566160" cy="256032"/>
+          </a:xfrm>
+          <a:prstGeom prst="rect">
+            <a:avLst/>
+          </a:prstGeom>
+          <a:noFill/>
+          <a:ln/>
+        </p:spPr>
+        <p:txBody>
+          <a:bodyPr wrap="square" lIns="0" tIns="0" rIns="0" bIns="0" rtlCol="0" anchor="ctr"/>
+          <a:lstStyle/>
+          <a:p>
+            <a:pPr indent="0" marL="0">
+              <a:buNone/>
+            </a:pPr>
+            <a:r>
+              <a:rPr lang="en-US" sz="1050" b="1" spc="300" kern="0" dirty="0">
+                <a:solidFill>
+                  <a:srgbClr val="0D9488"/>
+                </a:solidFill>
+                <a:latin typeface="Calibri" pitchFamily="34" charset="0"/>
+                <a:ea typeface="Calibri" pitchFamily="34" charset="-122"/>
+                <a:cs typeface="Calibri" pitchFamily="34" charset="-120"/>
+              </a:rPr>
+              <a:t>What the curves show</a:t>
+            </a:r>
+            <a:endParaRPr lang="en-US" sz="1050" dirty="0"/>
+          </a:p>
+        </p:txBody>
+      </p:sp>
+      <p:sp>
+        <p:nvSpPr>
+          <p:cNvPr id="9" name="Shape 6"/>
+          <p:cNvSpPr/>
+          <p:nvPr/>
+        </p:nvSpPr>
+        <p:spPr>
+          <a:xfrm>
+            <a:off x="5303520" y="1847088"/>
+            <a:ext cx="36576" cy="2697480"/>
           </a:xfrm>
           <a:prstGeom prst="rect">
             <a:avLst/>
           </a:prstGeom>
           <a:solidFill>
-            <a:srgbClr val="FFFFFF"/>
-          </a:solidFill>
-          <a:ln w="6350">
-            <a:solidFill>
-              <a:srgbClr val="E5E7EB"/>
-            </a:solidFill>
-            <a:prstDash val="solid"/>
-          </a:ln>
-          <a:effectLst>
-            <a:outerShdw sx="100000" sy="100000" kx="0" ky="0" algn="bl" rotWithShape="0" blurRad="63500" dist="19050" dir="5400000">
-              <a:srgbClr val="000000">
-                <a:alpha val="6000"/>
-              </a:srgbClr>
-            </a:outerShdw>
-          </a:effectLst>
-        </p:spPr>
-      </p:sp>
-      <p:sp>
-        <p:nvSpPr>
-          <p:cNvPr id="9" name="Shape 6"/>
-          <p:cNvSpPr/>
-          <p:nvPr/>
-        </p:nvSpPr>
-        <p:spPr>
-          <a:xfrm>
-            <a:off x="5303520" y="1554480"/>
-            <a:ext cx="64008" cy="822960"/>
-          </a:xfrm>
-          <a:prstGeom prst="rect">
-            <a:avLst/>
-          </a:prstGeom>
-          <a:solidFill>
-            <a:srgbClr val="0D9488"/>
+            <a:srgbClr val="0D9488">
+              <a:alpha val="70000"/>
+            </a:srgbClr>
           </a:solidFill>
           <a:ln w="12700">
             <a:solidFill>
@@ -6151,8 +6104,8 @@
         </p:nvSpPr>
         <p:spPr>
           <a:xfrm>
-            <a:off x="5486400" y="1645920"/>
-            <a:ext cx="3291840" cy="452628"/>
+            <a:off x="5468112" y="1865376"/>
+            <a:ext cx="3364992" cy="2697480"/>
           </a:xfrm>
           <a:prstGeom prst="rect">
             <a:avLst/>
@@ -6164,375 +6117,280 @@
           <a:bodyPr wrap="square" lIns="0" tIns="0" rIns="0" bIns="0" rtlCol="0" anchor="t"/>
           <a:lstStyle/>
           <a:p>
-            <a:pPr algn="l" indent="0" marL="0">
-              <a:buNone/>
-            </a:pPr>
-            <a:r>
-              <a:rPr lang="en-US" sz="2100" b="1" dirty="0">
+            <a:pPr indent="0" marL="0">
+              <a:spcAft>
+                <a:spcPts val="600"/>
+              </a:spcAft>
+              <a:buNone/>
+            </a:pPr>
+            <a:r>
+              <a:rPr lang="en-US" sz="1000" b="1" dirty="0">
                 <a:solidFill>
                   <a:srgbClr val="0D9488"/>
                 </a:solidFill>
-                <a:latin typeface="Georgia" pitchFamily="34" charset="0"/>
-                <a:ea typeface="Georgia" pitchFamily="34" charset="-122"/>
-                <a:cs typeface="Georgia" pitchFamily="34" charset="-120"/>
-              </a:rPr>
-              <a:t>0.8392  ✓</a:t>
-            </a:r>
-            <a:endParaRPr lang="en-US" sz="2100" dirty="0"/>
+                <a:latin typeface="Calibri" pitchFamily="34" charset="0"/>
+                <a:ea typeface="Calibri" pitchFamily="34" charset="-122"/>
+                <a:cs typeface="Calibri" pitchFamily="34" charset="-120"/>
+              </a:rPr>
+              <a:t>— </a:t>
+            </a:r>
+            <a:pPr indent="0" marL="0">
+              <a:spcAft>
+                <a:spcPts val="600"/>
+              </a:spcAft>
+              <a:buNone/>
+            </a:pPr>
+            <a:r>
+              <a:rPr lang="en-US" sz="1000" b="1" dirty="0">
+                <a:solidFill>
+                  <a:srgbClr val="334155"/>
+                </a:solidFill>
+                <a:latin typeface="Calibri" pitchFamily="34" charset="0"/>
+                <a:ea typeface="Calibri" pitchFamily="34" charset="-122"/>
+                <a:cs typeface="Calibri" pitchFamily="34" charset="-120"/>
+              </a:rPr>
+              <a:t>Smooth convergence</a:t>
+            </a:r>
+            <a:pPr indent="0" marL="0">
+              <a:spcAft>
+                <a:spcPts val="600"/>
+              </a:spcAft>
+              <a:buNone/>
+            </a:pPr>
+            <a:r>
+              <a:rPr lang="en-US" sz="900" i="1" dirty="0">
+                <a:solidFill>
+                  <a:srgbClr val="64748B"/>
+                </a:solidFill>
+                <a:latin typeface="Calibri" pitchFamily="34" charset="0"/>
+                <a:ea typeface="Calibri" pitchFamily="34" charset="-122"/>
+                <a:cs typeface="Calibri" pitchFamily="34" charset="-120"/>
+              </a:rPr>
+              <a:t>  train AUC rises to ~0.99; loss falls monotonically, no divergence</a:t>
+            </a:r>
+            <a:endParaRPr lang="en-US" sz="1000" dirty="0"/>
+          </a:p>
+          <a:p>
+            <a:pPr indent="0" marL="0">
+              <a:spcAft>
+                <a:spcPts val="600"/>
+              </a:spcAft>
+              <a:buNone/>
+            </a:pPr>
+            <a:r>
+              <a:rPr lang="en-US" sz="1000" b="1" dirty="0">
+                <a:solidFill>
+                  <a:srgbClr val="0D9488"/>
+                </a:solidFill>
+                <a:latin typeface="Calibri" pitchFamily="34" charset="0"/>
+                <a:ea typeface="Calibri" pitchFamily="34" charset="-122"/>
+                <a:cs typeface="Calibri" pitchFamily="34" charset="-120"/>
+              </a:rPr>
+              <a:t>— </a:t>
+            </a:r>
+            <a:pPr indent="0" marL="0">
+              <a:spcAft>
+                <a:spcPts val="600"/>
+              </a:spcAft>
+              <a:buNone/>
+            </a:pPr>
+            <a:r>
+              <a:rPr lang="en-US" sz="1000" b="1" dirty="0">
+                <a:solidFill>
+                  <a:srgbClr val="334155"/>
+                </a:solidFill>
+                <a:latin typeface="Calibri" pitchFamily="34" charset="0"/>
+                <a:ea typeface="Calibri" pitchFamily="34" charset="-122"/>
+                <a:cs typeface="Calibri" pitchFamily="34" charset="-120"/>
+              </a:rPr>
+              <a:t>12 epochs</a:t>
+            </a:r>
+            <a:pPr indent="0" marL="0">
+              <a:spcAft>
+                <a:spcPts val="600"/>
+              </a:spcAft>
+              <a:buNone/>
+            </a:pPr>
+            <a:r>
+              <a:rPr lang="en-US" sz="900" i="1" dirty="0">
+                <a:solidFill>
+                  <a:srgbClr val="64748B"/>
+                </a:solidFill>
+                <a:latin typeface="Calibri" pitchFamily="34" charset="0"/>
+                <a:ea typeface="Calibri" pitchFamily="34" charset="-122"/>
+                <a:cs typeface="Calibri" pitchFamily="34" charset="-120"/>
+              </a:rPr>
+              <a:t>  AdamW + OneCycleLR, batch 128, gradient clipping</a:t>
+            </a:r>
+            <a:endParaRPr lang="en-US" sz="1000" dirty="0"/>
+          </a:p>
+          <a:p>
+            <a:pPr indent="0" marL="0">
+              <a:spcAft>
+                <a:spcPts val="600"/>
+              </a:spcAft>
+              <a:buNone/>
+            </a:pPr>
+            <a:r>
+              <a:rPr lang="en-US" sz="1000" b="1" dirty="0">
+                <a:solidFill>
+                  <a:srgbClr val="0D9488"/>
+                </a:solidFill>
+                <a:latin typeface="Calibri" pitchFamily="34" charset="0"/>
+                <a:ea typeface="Calibri" pitchFamily="34" charset="-122"/>
+                <a:cs typeface="Calibri" pitchFamily="34" charset="-120"/>
+              </a:rPr>
+              <a:t>— </a:t>
+            </a:r>
+            <a:pPr indent="0" marL="0">
+              <a:spcAft>
+                <a:spcPts val="600"/>
+              </a:spcAft>
+              <a:buNone/>
+            </a:pPr>
+            <a:r>
+              <a:rPr lang="en-US" sz="1000" b="1" dirty="0">
+                <a:solidFill>
+                  <a:srgbClr val="334155"/>
+                </a:solidFill>
+                <a:latin typeface="Calibri" pitchFamily="34" charset="0"/>
+                <a:ea typeface="Calibri" pitchFamily="34" charset="-122"/>
+                <a:cs typeface="Calibri" pitchFamily="34" charset="-120"/>
+              </a:rPr>
+              <a:t>SWA (Izmailov 2018)</a:t>
+            </a:r>
+            <a:pPr indent="0" marL="0">
+              <a:spcAft>
+                <a:spcPts val="600"/>
+              </a:spcAft>
+              <a:buNone/>
+            </a:pPr>
+            <a:r>
+              <a:rPr lang="en-US" sz="900" i="1" dirty="0">
+                <a:solidFill>
+                  <a:srgbClr val="64748B"/>
+                </a:solidFill>
+                <a:latin typeface="Calibri" pitchFamily="34" charset="0"/>
+                <a:ea typeface="Calibri" pitchFamily="34" charset="-122"/>
+                <a:cs typeface="Calibri" pitchFamily="34" charset="-120"/>
+              </a:rPr>
+              <a:t>  weights averaged over the last epochs + a manual BN refresh</a:t>
+            </a:r>
+            <a:endParaRPr lang="en-US" sz="1000" dirty="0"/>
+          </a:p>
+          <a:p>
+            <a:pPr indent="0" marL="0">
+              <a:spcAft>
+                <a:spcPts val="600"/>
+              </a:spcAft>
+              <a:buNone/>
+            </a:pPr>
+            <a:r>
+              <a:rPr lang="en-US" sz="1000" b="1" dirty="0">
+                <a:solidFill>
+                  <a:srgbClr val="0D9488"/>
+                </a:solidFill>
+                <a:latin typeface="Calibri" pitchFamily="34" charset="0"/>
+                <a:ea typeface="Calibri" pitchFamily="34" charset="-122"/>
+                <a:cs typeface="Calibri" pitchFamily="34" charset="-120"/>
+              </a:rPr>
+              <a:t>— </a:t>
+            </a:r>
+            <a:pPr indent="0" marL="0">
+              <a:spcAft>
+                <a:spcPts val="600"/>
+              </a:spcAft>
+              <a:buNone/>
+            </a:pPr>
+            <a:r>
+              <a:rPr lang="en-US" sz="1000" b="1" dirty="0">
+                <a:solidFill>
+                  <a:srgbClr val="334155"/>
+                </a:solidFill>
+                <a:latin typeface="Calibri" pitchFamily="34" charset="0"/>
+                <a:ea typeface="Calibri" pitchFamily="34" charset="-122"/>
+                <a:cs typeface="Calibri" pitchFamily="34" charset="-120"/>
+              </a:rPr>
+              <a:t>Per-patient MIL aux</a:t>
+            </a:r>
+            <a:pPr indent="0" marL="0">
+              <a:spcAft>
+                <a:spcPts val="600"/>
+              </a:spcAft>
+              <a:buNone/>
+            </a:pPr>
+            <a:r>
+              <a:rPr lang="en-US" sz="900" i="1" dirty="0">
+                <a:solidFill>
+                  <a:srgbClr val="64748B"/>
+                </a:solidFill>
+                <a:latin typeface="Calibri" pitchFamily="34" charset="0"/>
+                <a:ea typeface="Calibri" pitchFamily="34" charset="-122"/>
+                <a:cs typeface="Calibri" pitchFamily="34" charset="-120"/>
+              </a:rPr>
+              <a:t>  regularises against within-patient memorisation</a:t>
+            </a:r>
+            <a:endParaRPr lang="en-US" sz="1000" dirty="0"/>
+          </a:p>
+          <a:p>
+            <a:pPr indent="0" marL="0">
+              <a:spcAft>
+                <a:spcPts val="600"/>
+              </a:spcAft>
+              <a:buNone/>
+            </a:pPr>
+            <a:r>
+              <a:rPr lang="en-US" sz="1000" b="1" dirty="0">
+                <a:solidFill>
+                  <a:srgbClr val="0D9488"/>
+                </a:solidFill>
+                <a:latin typeface="Calibri" pitchFamily="34" charset="0"/>
+                <a:ea typeface="Calibri" pitchFamily="34" charset="-122"/>
+                <a:cs typeface="Calibri" pitchFamily="34" charset="-120"/>
+              </a:rPr>
+              <a:t>— </a:t>
+            </a:r>
+            <a:pPr indent="0" marL="0">
+              <a:spcAft>
+                <a:spcPts val="600"/>
+              </a:spcAft>
+              <a:buNone/>
+            </a:pPr>
+            <a:r>
+              <a:rPr lang="en-US" sz="1000" b="1" dirty="0">
+                <a:solidFill>
+                  <a:srgbClr val="334155"/>
+                </a:solidFill>
+                <a:latin typeface="Calibri" pitchFamily="34" charset="0"/>
+                <a:ea typeface="Calibri" pitchFamily="34" charset="-122"/>
+                <a:cs typeface="Calibri" pitchFamily="34" charset="-120"/>
+              </a:rPr>
+              <a:t>No held-out val</a:t>
+            </a:r>
+            <a:pPr indent="0" marL="0">
+              <a:spcAft>
+                <a:spcPts val="600"/>
+              </a:spcAft>
+              <a:buNone/>
+            </a:pPr>
+            <a:r>
+              <a:rPr lang="en-US" sz="900" i="1" dirty="0">
+                <a:solidFill>
+                  <a:srgbClr val="64748B"/>
+                </a:solidFill>
+                <a:latin typeface="Calibri" pitchFamily="34" charset="0"/>
+                <a:ea typeface="Calibri" pitchFamily="34" charset="-122"/>
+                <a:cs typeface="Calibri" pitchFamily="34" charset="-120"/>
+              </a:rPr>
+              <a:t>  N=12 is too small; the public LB is the external check</a:t>
+            </a:r>
+            <a:endParaRPr lang="en-US" sz="1000" dirty="0"/>
           </a:p>
         </p:txBody>
       </p:sp>
       <p:sp>
         <p:nvSpPr>
           <p:cNvPr id="11" name="Text 8"/>
-          <p:cNvSpPr/>
-          <p:nvPr/>
-        </p:nvSpPr>
-        <p:spPr>
-          <a:xfrm>
-            <a:off x="5486400" y="2007108"/>
-            <a:ext cx="3291840" cy="370332"/>
-          </a:xfrm>
-          <a:prstGeom prst="rect">
-            <a:avLst/>
-          </a:prstGeom>
-          <a:noFill/>
-          <a:ln/>
-        </p:spPr>
-        <p:txBody>
-          <a:bodyPr wrap="square" lIns="0" tIns="0" rIns="0" bIns="0" rtlCol="0" anchor="t"/>
-          <a:lstStyle/>
-          <a:p>
-            <a:pPr algn="l" indent="0" marL="0">
-              <a:buNone/>
-            </a:pPr>
-            <a:r>
-              <a:rPr lang="en-US" sz="900" dirty="0">
-                <a:solidFill>
-                  <a:srgbClr val="64748B"/>
-                </a:solidFill>
-                <a:latin typeface="Calibri" pitchFamily="34" charset="0"/>
-                <a:ea typeface="Calibri" pitchFamily="34" charset="-122"/>
-                <a:cs typeface="Calibri" pitchFamily="34" charset="-120"/>
-              </a:rPr>
-              <a:t>intermediate CO-ATTENTION (CAFNet-style) — new best, beats v47's 0.8355</a:t>
-            </a:r>
-            <a:endParaRPr lang="en-US" sz="900" dirty="0"/>
-          </a:p>
-        </p:txBody>
-      </p:sp>
-      <p:sp>
-        <p:nvSpPr>
-          <p:cNvPr id="12" name="Shape 9"/>
-          <p:cNvSpPr/>
-          <p:nvPr/>
-        </p:nvSpPr>
-        <p:spPr>
-          <a:xfrm>
-            <a:off x="5303520" y="2468880"/>
-            <a:ext cx="3566160" cy="822960"/>
-          </a:xfrm>
-          <a:prstGeom prst="rect">
-            <a:avLst/>
-          </a:prstGeom>
-          <a:solidFill>
-            <a:srgbClr val="FFFFFF"/>
-          </a:solidFill>
-          <a:ln w="6350">
-            <a:solidFill>
-              <a:srgbClr val="E5E7EB"/>
-            </a:solidFill>
-            <a:prstDash val="solid"/>
-          </a:ln>
-          <a:effectLst>
-            <a:outerShdw sx="100000" sy="100000" kx="0" ky="0" algn="bl" rotWithShape="0" blurRad="63500" dist="19050" dir="5400000">
-              <a:srgbClr val="000000">
-                <a:alpha val="6000"/>
-              </a:srgbClr>
-            </a:outerShdw>
-          </a:effectLst>
-        </p:spPr>
-      </p:sp>
-      <p:sp>
-        <p:nvSpPr>
-          <p:cNvPr id="13" name="Shape 10"/>
-          <p:cNvSpPr/>
-          <p:nvPr/>
-        </p:nvSpPr>
-        <p:spPr>
-          <a:xfrm>
-            <a:off x="5303520" y="2468880"/>
-            <a:ext cx="64008" cy="822960"/>
-          </a:xfrm>
-          <a:prstGeom prst="rect">
-            <a:avLst/>
-          </a:prstGeom>
-          <a:solidFill>
-            <a:srgbClr val="B91C1C"/>
-          </a:solidFill>
-          <a:ln w="12700">
-            <a:solidFill>
-              <a:srgbClr val="B91C1C"/>
-            </a:solidFill>
-            <a:prstDash val="solid"/>
-          </a:ln>
-        </p:spPr>
-      </p:sp>
-      <p:sp>
-        <p:nvSpPr>
-          <p:cNvPr id="14" name="Text 11"/>
-          <p:cNvSpPr/>
-          <p:nvPr/>
-        </p:nvSpPr>
-        <p:spPr>
-          <a:xfrm>
-            <a:off x="5486400" y="2560320"/>
-            <a:ext cx="3291840" cy="452628"/>
-          </a:xfrm>
-          <a:prstGeom prst="rect">
-            <a:avLst/>
-          </a:prstGeom>
-          <a:noFill/>
-          <a:ln/>
-        </p:spPr>
-        <p:txBody>
-          <a:bodyPr wrap="square" lIns="0" tIns="0" rIns="0" bIns="0" rtlCol="0" anchor="t"/>
-          <a:lstStyle/>
-          <a:p>
-            <a:pPr algn="l" indent="0" marL="0">
-              <a:buNone/>
-            </a:pPr>
-            <a:r>
-              <a:rPr lang="en-US" sz="2100" b="1" dirty="0">
-                <a:solidFill>
-                  <a:srgbClr val="B91C1C"/>
-                </a:solidFill>
-                <a:latin typeface="Georgia" pitchFamily="34" charset="0"/>
-                <a:ea typeface="Georgia" pitchFamily="34" charset="-122"/>
-                <a:cs typeface="Georgia" pitchFamily="34" charset="-120"/>
-              </a:rPr>
-              <a:t>0.7823  ✗</a:t>
-            </a:r>
-            <a:endParaRPr lang="en-US" sz="2100" dirty="0"/>
-          </a:p>
-        </p:txBody>
-      </p:sp>
-      <p:sp>
-        <p:nvSpPr>
-          <p:cNvPr id="15" name="Text 12"/>
-          <p:cNvSpPr/>
-          <p:nvPr/>
-        </p:nvSpPr>
-        <p:spPr>
-          <a:xfrm>
-            <a:off x="5486400" y="2921508"/>
-            <a:ext cx="3291840" cy="370332"/>
-          </a:xfrm>
-          <a:prstGeom prst="rect">
-            <a:avLst/>
-          </a:prstGeom>
-          <a:noFill/>
-          <a:ln/>
-        </p:spPr>
-        <p:txBody>
-          <a:bodyPr wrap="square" lIns="0" tIns="0" rIns="0" bIns="0" rtlCol="0" anchor="t"/>
-          <a:lstStyle/>
-          <a:p>
-            <a:pPr algn="l" indent="0" marL="0">
-              <a:buNone/>
-            </a:pPr>
-            <a:r>
-              <a:rPr lang="en-US" sz="900" dirty="0">
-                <a:solidFill>
-                  <a:srgbClr val="64748B"/>
-                </a:solidFill>
-                <a:latin typeface="Calibri" pitchFamily="34" charset="0"/>
-                <a:ea typeface="Calibri" pitchFamily="34" charset="-122"/>
-                <a:cs typeface="Calibri" pitchFamily="34" charset="-120"/>
-              </a:rPr>
-              <a:t>higher resolution (192 px) — regressed</a:t>
-            </a:r>
-            <a:endParaRPr lang="en-US" sz="900" dirty="0"/>
-          </a:p>
-        </p:txBody>
-      </p:sp>
-      <p:sp>
-        <p:nvSpPr>
-          <p:cNvPr id="16" name="Shape 13"/>
-          <p:cNvSpPr/>
-          <p:nvPr/>
-        </p:nvSpPr>
-        <p:spPr>
-          <a:xfrm>
-            <a:off x="5303520" y="3383280"/>
-            <a:ext cx="3566160" cy="822960"/>
-          </a:xfrm>
-          <a:prstGeom prst="rect">
-            <a:avLst/>
-          </a:prstGeom>
-          <a:solidFill>
-            <a:srgbClr val="FFFFFF"/>
-          </a:solidFill>
-          <a:ln w="6350">
-            <a:solidFill>
-              <a:srgbClr val="E5E7EB"/>
-            </a:solidFill>
-            <a:prstDash val="solid"/>
-          </a:ln>
-          <a:effectLst>
-            <a:outerShdw sx="100000" sy="100000" kx="0" ky="0" algn="bl" rotWithShape="0" blurRad="63500" dist="19050" dir="5400000">
-              <a:srgbClr val="000000">
-                <a:alpha val="6000"/>
-              </a:srgbClr>
-            </a:outerShdw>
-          </a:effectLst>
-        </p:spPr>
-      </p:sp>
-      <p:sp>
-        <p:nvSpPr>
-          <p:cNvPr id="17" name="Shape 14"/>
-          <p:cNvSpPr/>
-          <p:nvPr/>
-        </p:nvSpPr>
-        <p:spPr>
-          <a:xfrm>
-            <a:off x="5303520" y="3383280"/>
-            <a:ext cx="64008" cy="822960"/>
-          </a:xfrm>
-          <a:prstGeom prst="rect">
-            <a:avLst/>
-          </a:prstGeom>
-          <a:solidFill>
-            <a:srgbClr val="B91C1C"/>
-          </a:solidFill>
-          <a:ln w="12700">
-            <a:solidFill>
-              <a:srgbClr val="B91C1C"/>
-            </a:solidFill>
-            <a:prstDash val="solid"/>
-          </a:ln>
-        </p:spPr>
-      </p:sp>
-      <p:sp>
-        <p:nvSpPr>
-          <p:cNvPr id="18" name="Text 15"/>
-          <p:cNvSpPr/>
-          <p:nvPr/>
-        </p:nvSpPr>
-        <p:spPr>
-          <a:xfrm>
-            <a:off x="5486400" y="3474720"/>
-            <a:ext cx="3291840" cy="452628"/>
-          </a:xfrm>
-          <a:prstGeom prst="rect">
-            <a:avLst/>
-          </a:prstGeom>
-          <a:noFill/>
-          <a:ln/>
-        </p:spPr>
-        <p:txBody>
-          <a:bodyPr wrap="square" lIns="0" tIns="0" rIns="0" bIns="0" rtlCol="0" anchor="t"/>
-          <a:lstStyle/>
-          <a:p>
-            <a:pPr algn="l" indent="0" marL="0">
-              <a:buNone/>
-            </a:pPr>
-            <a:r>
-              <a:rPr lang="en-US" sz="2100" b="1" dirty="0">
-                <a:solidFill>
-                  <a:srgbClr val="B91C1C"/>
-                </a:solidFill>
-                <a:latin typeface="Georgia" pitchFamily="34" charset="0"/>
-                <a:ea typeface="Georgia" pitchFamily="34" charset="-122"/>
-                <a:cs typeface="Georgia" pitchFamily="34" charset="-120"/>
-              </a:rPr>
-              <a:t>0.7376  ✗</a:t>
-            </a:r>
-            <a:endParaRPr lang="en-US" sz="2100" dirty="0"/>
-          </a:p>
-        </p:txBody>
-      </p:sp>
-      <p:sp>
-        <p:nvSpPr>
-          <p:cNvPr id="19" name="Text 16"/>
-          <p:cNvSpPr/>
-          <p:nvPr/>
-        </p:nvSpPr>
-        <p:spPr>
-          <a:xfrm>
-            <a:off x="5486400" y="3835908"/>
-            <a:ext cx="3291840" cy="370332"/>
-          </a:xfrm>
-          <a:prstGeom prst="rect">
-            <a:avLst/>
-          </a:prstGeom>
-          <a:noFill/>
-          <a:ln/>
-        </p:spPr>
-        <p:txBody>
-          <a:bodyPr wrap="square" lIns="0" tIns="0" rIns="0" bIns="0" rtlCol="0" anchor="t"/>
-          <a:lstStyle/>
-          <a:p>
-            <a:pPr algn="l" indent="0" marL="0">
-              <a:buNone/>
-            </a:pPr>
-            <a:r>
-              <a:rPr lang="en-US" sz="900" dirty="0">
-                <a:solidFill>
-                  <a:srgbClr val="64748B"/>
-                </a:solidFill>
-                <a:latin typeface="Calibri" pitchFamily="34" charset="0"/>
-                <a:ea typeface="Calibri" pitchFamily="34" charset="-122"/>
-                <a:cs typeface="Calibri" pitchFamily="34" charset="-120"/>
-              </a:rPr>
-              <a:t>more capacity (EfficientNetV2-S) — regressed</a:t>
-            </a:r>
-            <a:endParaRPr lang="en-US" sz="900" dirty="0"/>
-          </a:p>
-        </p:txBody>
-      </p:sp>
-      <p:sp>
-        <p:nvSpPr>
-          <p:cNvPr id="20" name="Text 17"/>
-          <p:cNvSpPr/>
-          <p:nvPr/>
-        </p:nvSpPr>
-        <p:spPr>
-          <a:xfrm>
-            <a:off x="5303520" y="4334256"/>
-            <a:ext cx="3566160" cy="502920"/>
-          </a:xfrm>
-          <a:prstGeom prst="rect">
-            <a:avLst/>
-          </a:prstGeom>
-          <a:noFill/>
-          <a:ln/>
-        </p:spPr>
-        <p:txBody>
-          <a:bodyPr wrap="square" lIns="0" tIns="0" rIns="0" bIns="0" rtlCol="0" anchor="ctr"/>
-          <a:lstStyle/>
-          <a:p>
-            <a:pPr indent="0" marL="0">
-              <a:buNone/>
-            </a:pPr>
-            <a:r>
-              <a:rPr lang="en-US" sz="950" i="1" dirty="0">
-                <a:solidFill>
-                  <a:srgbClr val="334155"/>
-                </a:solidFill>
-                <a:latin typeface="Calibri" pitchFamily="34" charset="0"/>
-                <a:ea typeface="Calibri" pitchFamily="34" charset="-122"/>
-                <a:cs typeface="Calibri" pitchFamily="34" charset="-120"/>
-              </a:rPr>
-              <a:t>Of every architecture tried, only fusion design moved the needle — the model is data-bound. Capacity and resolution both hurt.</a:t>
-            </a:r>
-            <a:endParaRPr lang="en-US" sz="950" dirty="0"/>
-          </a:p>
-        </p:txBody>
-      </p:sp>
-      <p:sp>
-        <p:nvSpPr>
-          <p:cNvPr id="21" name="Text 18"/>
           <p:cNvSpPr/>
           <p:nvPr/>
         </p:nvSpPr>
@@ -6571,7 +6429,7 @@
       </p:sp>
       <p:sp>
         <p:nvSpPr>
-          <p:cNvPr id="22" name="Text 19"/>
+          <p:cNvPr id="12" name="Text 9"/>
           <p:cNvSpPr/>
           <p:nvPr/>
         </p:nvSpPr>
@@ -7244,7 +7102,7 @@
                 <a:ea typeface="Calibri" pitchFamily="34" charset="-122"/>
                 <a:cs typeface="Calibri" pitchFamily="34" charset="-120"/>
               </a:rPr>
-              <a:t>Four regularisers gained +0.011; soft-pseudo distillation gained +0.042. Even the SOTA co-attention fusion ≈ plain late fusion (0.97 corr, both 0.83). Only co-attention fusion nudged architecture (+0.004 to a new best 0.8392); data was ~10x bigger.</a:t>
+              <a:t>Four regularisers gained +0.011; soft-pseudo distillation gained +0.042 — about 4× more lift from growing the effective dataset than from any architecture or regulariser change.</a:t>
             </a:r>
             <a:endParaRPr lang="en-US" sz="1050" dirty="0"/>
           </a:p>
@@ -8155,7 +8013,7 @@
                 <a:ea typeface="Georgia" pitchFamily="34" charset="-122"/>
                 <a:cs typeface="Georgia" pitchFamily="34" charset="-120"/>
               </a:rPr>
-              <a:t>0.8392</a:t>
+              <a:t>0.8355</a:t>
             </a:r>
             <a:endParaRPr lang="en-US" sz="2400" dirty="0"/>
           </a:p>
@@ -8194,7 +8052,7 @@
                 <a:ea typeface="Calibri" pitchFamily="34" charset="-122"/>
                 <a:cs typeface="Calibri" pitchFamily="34" charset="-120"/>
               </a:rPr>
-              <a:t>BEST LB  ·  v58 co-attention</a:t>
+              <a:t>BEST LB  ·  v47 distillation</a:t>
             </a:r>
             <a:endParaRPr lang="en-US" sz="950" dirty="0"/>
           </a:p>
@@ -10754,7 +10612,7 @@
                 <a:ea typeface="Georgia" pitchFamily="34" charset="-122"/>
                 <a:cs typeface="Georgia" pitchFamily="34" charset="-120"/>
               </a:rPr>
-              <a:t>+0.094 LB total — the biggest single jump (+0.039) was soft-pseudo distillation (Hinton 2015).</a:t>
+              <a:t>+0.081 LB total — the biggest single jump (+0.039) was soft-pseudo distillation (Hinton 2015).</a:t>
             </a:r>
             <a:endParaRPr lang="en-US" sz="950" dirty="0"/>
           </a:p>

</xml_diff>

<commit_message>
deck: scope presentation to v47, drop within-noise co-attention work (#20)
The post-v47 work (co-attention 0.8392, the EfficientNetV2-S / 192px sweep, the
0.8404 blend) all sat within the seed-noise floor -- no real improvement -- and
is hard to fit in a 10-minute talk. Scoped the slide deck to the substantive v47
distillation story:
- title + slide-2 card: best public LB 0.8355 (v47 distillation), lift +0.090
- lb_progression chart trimmed to end at v47 (dropped v58-v61 + the co-attention annotation)
- slide 12 rescoped to v47-era ensembling evidence (dropped the v61/blend bullet)
- slide 13 repurposed from the co-attention "final push" into a learning-curves
  slide (v47 curves) -- keeps the teacher-required learning curves
- take-home #4, speaker notes, alt-text: de-co-attention'd

README and LB_HISTORY keep the full record (co-attention noted as within-noise);
only the presentation is scoped.
</commit_message>
<xml_diff>
--- a/presentation/A3_cancer_challenge.pptx
+++ b/presentation/A3_cancer_challenge.pptx
@@ -515,7 +515,7 @@
           <a:p>
             <a:r>
               <a:rPr lang="en-US" dirty="0"/>
-              <a:t>Hello — I'm Rafael. Today I'll walk you through the Multimodal Cancer Cell Classification Challenge: 30+ logged Kaggle versions, five acts of experimentation, and a final architecture push. +0.094 LB lift over the supervised baseline to my best single model: v58's intermediate co-attention fusion (seed2) at 0.8392 -- the new best.
+              <a:t>Hello — I'm Rafael. Today I'll walk you through the Multimodal Cancer Cell Classification Challenge: 30+ logged Kaggle versions across five acts of experimentation. +0.090 LB lift over the supervised baseline, via pseudo-labels and Hinton-style distillation, to a best public LB of 0.8355.
 But this talk is not primarily about the score. The instructor said grading is based on methodology and presentation, not the leaderboard itself. So I'll spend most of the time on what didn't work and why — six diagnosed failures shaped the winning recipe directly.
 Pacing: 14 slides, ~45 seconds per slide, ~30 seconds buffer for questions.</a:t>
             </a:r>
@@ -614,8 +614,7 @@
 - v45_probe at 0.7729 confirms cross-recipe ensembles fail at 0.025 LB gaps.
 - v46 at 0.8236 is the distillation breakthrough.
 - v47 (iterative noisy student round 2, Xie 2020): 0.8264 ensemble, 0.8355 best single seed.
-- The right-edge cluster is the final single-model architecture sweep: v58 intermediate co-attention reached 0.8392 (the new best, amber); v59 (EfficientNetV2-S) and v60 (192px) both regressed; and v61's 2-seed co-attention average (0.8308) landed below the best seed -- ensembling failing yet again.
-The +0.094 LB lift from v19 (0.7455) to v58's co-attention best (0.8392) is the headline -- the next two slides cover why ensembling never helped, and the co-attention final push that set that best.</a:t>
+The +0.090 LB lift from v19 (0.7455) to v47's best seed (0.8355), driven by the pseudo-label and distillation pipeline, is the headline. The next slide covers why ensembling never beat the best single seed on this data.</a:t>
             </a:r>
             <a:endParaRPr lang="en-US" dirty="0"/>
           </a:p>
@@ -798,11 +797,11 @@
           <a:p>
             <a:r>
               <a:rPr lang="en-US" dirty="0"/>
-              <a:t>This is a slide I want you to remember: on this problem, ensembling never gave a lift beyond noise. I tried a dozen flavours; all but one regressed below my best single model, and the one that edged it did so by about 0.1 sigma -- a tie.
-Within-recipe seed averaging: my three v47 seeds average to 0.8264, but the best single seed is 0.8355. I confirmed it a second time on the winning co-attention recipe — v61's two-seed average scored 0.8308, below its best seed 0.8350. The per-seed leaderboard spread is ~0.023 on twelve patients — so wide that averaging doesn't cancel noise, it just drags the lucky draw back down to the mean.
-Cross-recipe averaging: v22 averaged v19 and v21 and landed at 0.7422, below v19's 0.7455 alone. v45_probe confirmed it. Symmetric averaging always pulls toward the weaker member, and the quality gap between any two of my models is wide enough that it hurts.
-And the one that should have worked: a gradient-boosted tree on hand-crafted features, genuinely decorrelated from the CNN at rank-correlation 0.41 — textbook ideal ensemble ingredient. Its leave-patients-out CV was 0.82. Blended 50/50 with my best model it scored 0.7074. Its CV simply did not transfer to unseen patients — the exact CV-versus-LB trap that defines this whole project, now sprung on the ensemble itself.
-The conclusion: with twelve patients, variance dominates, and no averaging gives a lift beyond noise -- the one within-rule blend only tied the best single (0.8404 vs 0.8392, ~0.1 sigma). For the final lock-in I chose robustness over the lucky draw: two variance-reduced models -- v58's 2-seed co-attention mean (0.8314) and v47's 3-seed distillation ensemble (0.8264) -- neither dependent on a single lucky seed.</a:t>
+              <a:t>This is a slide I want you to remember: on this problem, ensembling never gave a lift beyond noise. Every ensemble I tried scored below my best single seed.
+Within-recipe seed averaging: my three v47 seeds average to 0.8264, but the best single seed is 0.8355. The per-seed leaderboard spread is ~0.023 on twelve patients — so wide that averaging doesn't cancel noise, it just drags the lucky draw back down to the mean.
+Cross-recipe averaging: v22 averaged v19 and v21 and landed at 0.7422, below v19's 0.7455 alone. v45_probe confirmed it. Symmetric averaging pulls toward the weaker member, and the quality gap between any two of my models is wide enough that it hurts.
+And the one that should have worked: a gradient-boosted tree on hand-crafted features, genuinely decorrelated from the CNN at rank-correlation 0.41 — a textbook ensemble ingredient. Its leave-patients-out CV was 0.82. Blended 50/50 with my best model it scored 0.7074 — its CV simply did not transfer to unseen patients, the exact CV-versus-LB trap that defines this whole project.
+So averaging never raised the score on twelve patients -- but it does cut seed variance. For a single hidden-split bet that robustness matters more than a lucky seed's fragile edge, so my final picks are variance-reduced ensembles, not the lucky single seed.</a:t>
             </a:r>
             <a:endParaRPr lang="en-US" dirty="0"/>
           </a:p>
@@ -890,10 +889,9 @@
           <a:p>
             <a:r>
               <a:rPr lang="en-US" dirty="0"/>
-              <a:t>The final chapter, after the distillation breakthrough. I swept the remaining architectural levers as single EfficientNet models — no ensembles (those all failed; next slide).
-Two hurt: bumping capacity to EfficientNetV2-S dropped to 0.7376 (a bigger model overfits 12 patients), and raising input resolution to 192px dropped to 0.7823. Both reinforce the data-bound thesis.
-One helped: intermediate co-attention fusion — the CAFNet design from the source-dataset paper, applied to EfficientNet-B0. Its best seed reached 0.8392, a new best over v47's 0.8355, and it lifted the mean too. The learning curves (left) show clean training to ~0.99 train AUC with no instability — I had to harden the attention (fp32 + a zero-init ReZero gate) to stop an fp16 NaN.
-Take-home: fusion design is the one architectural lever that moved the needle here; capacity and resolution did not.</a:t>
+              <a:t>The teacher asked for learning curves, so here they are -- the v47 distillation run. The point is that training is clean and stable: per-cell train AUC climbs smoothly to about 0.99 and the loss falls monotonically, with no divergence, across seeds.
+The recipe: twelve epochs, AdamW with OneCycle, batch 128, gradient clipping; SWA over the last few epochs (Izmailov 2018) with a manual BN refresh for the two-input model; and the per-patient MIL auxiliary loss that regularises against memorising within-patient quirks.
+One thing to flag: there is no held-out validation set. With only twelve patients a held-out split is too noisy (v27 showed that), so the public leaderboard is the external check throughout.</a:t>
             </a:r>
             <a:endParaRPr lang="en-US" dirty="0"/>
           </a:p>
@@ -2396,7 +2394,7 @@
                 <a:ea typeface="Georgia" pitchFamily="34" charset="-122"/>
                 <a:cs typeface="Georgia" pitchFamily="34" charset="-120"/>
               </a:rPr>
-              <a:t>0.8392</a:t>
+              <a:t>0.8355</a:t>
             </a:r>
             <a:endParaRPr lang="en-US" sz="3600" dirty="0"/>
           </a:p>
@@ -2435,7 +2433,7 @@
                 <a:ea typeface="Calibri" pitchFamily="34" charset="-122"/>
                 <a:cs typeface="Calibri" pitchFamily="34" charset="-120"/>
               </a:rPr>
-              <a:t>v58 co-attention seed2  ·  single model</a:t>
+              <a:t>v47 noisy-student distillation</a:t>
             </a:r>
             <a:endParaRPr lang="en-US" sz="950" dirty="0"/>
           </a:p>
@@ -2513,7 +2511,7 @@
                 <a:ea typeface="Georgia" pitchFamily="34" charset="-122"/>
                 <a:cs typeface="Georgia" pitchFamily="34" charset="-120"/>
               </a:rPr>
-              <a:t>+0.094</a:t>
+              <a:t>+0.090</a:t>
             </a:r>
             <a:endParaRPr lang="en-US" sz="2000" dirty="0"/>
           </a:p>
@@ -2970,7 +2968,7 @@
       </p:sp>
       <p:pic>
         <p:nvPicPr>
-          <p:cNvPr id="6" name="Image 0" descr="Public LB progression across 30+ logged Kaggle submissions: v19 baseline 0.7455 → v47_s2 distillation seed 0.8355 → v58 intermediate co-attention 0.8392, the new best. v59 (EfficientNetV2-S) and v60 (192px) regressed; the v61 2-seed average sits below the best seed.">    </p:cNvPr>
+          <p:cNvPr id="6" name="Image 0" descr="Public LB progression across 30+ logged Kaggle submissions: v19 baseline 0.7455 rising to v47 distillation (0.8264 ensemble / 0.8355 best seed). The biggest jumps come from hard then soft pseudo-labels (v44, v46).">    </p:cNvPr>
           <p:cNvPicPr>
             <a:picLocks noChangeAspect="1"/>
           </p:cNvPicPr>
@@ -3025,7 +3023,7 @@
                 <a:ea typeface="Calibri" pitchFamily="34" charset="-122"/>
                 <a:cs typeface="Calibri" pitchFamily="34" charset="-120"/>
               </a:rPr>
-              <a:t>Fig. 4  Public LB across 30+ logged submissions. Amber = co-attention (new best) · green = pseudo-label breakthrough · blue = useful gain · red = regression · grey = neutral.</a:t>
+              <a:t>Fig. 4  Public LB across 30+ logged submissions. Green = pseudo-label breakthrough · blue = useful gain · red = regression · grey = neutral.</a:t>
             </a:r>
             <a:endParaRPr lang="en-US" sz="900" dirty="0"/>
           </a:p>
@@ -5045,7 +5043,7 @@
                 <a:ea typeface="Georgia" pitchFamily="34" charset="-122"/>
                 <a:cs typeface="Georgia" pitchFamily="34" charset="-120"/>
               </a:rPr>
-              <a:t>Ensembling never beat the best single model — beyond noise</a:t>
+              <a:t>Ensembling never beat the best single seed</a:t>
             </a:r>
             <a:endParaRPr lang="en-US" sz="2600" dirty="0"/>
           </a:p>
@@ -5553,7 +5551,7 @@
                 <a:ea typeface="Calibri" pitchFamily="34" charset="-122"/>
                 <a:cs typeface="Calibri" pitchFamily="34" charset="-120"/>
               </a:rPr>
-              <a:t>  v47's 3-seed mean (0.8264) fell below its best seed (0.8355); v61's 2-seed mean (0.8308) fell below its best (0.8350). Per-seed LB spans ~0.023 on N=12 — variance, not signal to average out.</a:t>
+              <a:t>  v47's 3-seed mean (0.8264) fell below its best seed (0.8355). Per-seed LB spans ~0.023 on N=12 — variance, not signal to average out.</a:t>
             </a:r>
             <a:endParaRPr lang="en-US" sz="1050" dirty="0"/>
           </a:p>
@@ -5608,60 +5606,6 @@
                 <a:cs typeface="Calibri" pitchFamily="34" charset="-120"/>
               </a:rPr>
               <a:t>  v22 (0.7422) fell below v19 (0.7455); a decorrelated feature-GBM blend scored 0.7074 — its leave-patients-out CV (0.82) did not transfer to unseen patients.</a:t>
-            </a:r>
-            <a:endParaRPr lang="en-US" sz="1050" dirty="0"/>
-          </a:p>
-          <a:p>
-            <a:pPr indent="0" marL="0">
-              <a:spcAft>
-                <a:spcPts val="600"/>
-              </a:spcAft>
-              <a:buNone/>
-            </a:pPr>
-            <a:r>
-              <a:rPr lang="en-US" sz="1050" b="1" dirty="0">
-                <a:solidFill>
-                  <a:srgbClr val="B91C1C"/>
-                </a:solidFill>
-                <a:latin typeface="Calibri" pitchFamily="34" charset="0"/>
-                <a:ea typeface="Calibri" pitchFamily="34" charset="-122"/>
-                <a:cs typeface="Calibri" pitchFamily="34" charset="-120"/>
-              </a:rPr>
-              <a:t>— </a:t>
-            </a:r>
-            <a:pPr indent="0" marL="0">
-              <a:spcAft>
-                <a:spcPts val="600"/>
-              </a:spcAft>
-              <a:buNone/>
-            </a:pPr>
-            <a:r>
-              <a:rPr lang="en-US" sz="1050" b="1" dirty="0">
-                <a:solidFill>
-                  <a:srgbClr val="334155"/>
-                </a:solidFill>
-                <a:latin typeface="Calibri" pitchFamily="34" charset="0"/>
-                <a:ea typeface="Calibri" pitchFamily="34" charset="-122"/>
-                <a:cs typeface="Calibri" pitchFamily="34" charset="-120"/>
-              </a:rPr>
-              <a:t>The one exception is within noise.</a:t>
-            </a:r>
-            <a:pPr indent="0" marL="0">
-              <a:spcAft>
-                <a:spcPts val="600"/>
-              </a:spcAft>
-              <a:buNone/>
-            </a:pPr>
-            <a:r>
-              <a:rPr lang="en-US" sz="950" i="1" dirty="0">
-                <a:solidFill>
-                  <a:srgbClr val="64748B"/>
-                </a:solidFill>
-                <a:latin typeface="Calibri" pitchFamily="34" charset="0"/>
-                <a:ea typeface="Calibri" pitchFamily="34" charset="-122"/>
-                <a:cs typeface="Calibri" pitchFamily="34" charset="-120"/>
-              </a:rPr>
-              <a:t>  A weighted blend of my two best, near-tied, different-recipe models (v58 + v47, 0.0037 apart) reached 0.8404 — but that is +0.0012 over the best single seed, about 0.1σ against the seed-noise floor. A statistical tie, not a lift.</a:t>
             </a:r>
             <a:endParaRPr lang="en-US" sz="1050" dirty="0"/>
           </a:p>
@@ -5913,7 +5857,7 @@
                 <a:ea typeface="Calibri" pitchFamily="34" charset="-122"/>
                 <a:cs typeface="Calibri" pitchFamily="34" charset="-120"/>
               </a:rPr>
-              <a:t>§11  ·  THE FINAL PUSH</a:t>
+              <a:t>§11  ·  TRAINING DYNAMICS</a:t>
             </a:r>
             <a:endParaRPr lang="en-US" sz="1050" dirty="0"/>
           </a:p>
@@ -6018,7 +5962,7 @@
                 <a:ea typeface="Georgia" pitchFamily="34" charset="-122"/>
                 <a:cs typeface="Georgia" pitchFamily="34" charset="-120"/>
               </a:rPr>
-              <a:t>Co-attention broke the plateau — a new best, 0.8392</a:t>
+              <a:t>Clean, stable training — no divergence on 12 patients</a:t>
             </a:r>
             <a:endParaRPr lang="en-US" sz="2600" dirty="0"/>
           </a:p>
@@ -6026,7 +5970,7 @@
       </p:sp>
       <p:pic>
         <p:nvPicPr>
-          <p:cNvPr id="6" name="Image 0" descr="Training curves for the v58 co-attention model: per-cell train AUC climbs smoothly from ~0.83 to ~0.99 over 12 epochs for both seeds, and loss decreases monotonically with no divergence (fp32 attention + ReZero gate kept it stable).">    </p:cNvPr>
+          <p:cNvPr id="6" name="Image 0" descr="Training curves for the v47 distillation model: per-cell train AUC climbs smoothly to about 0.99 over 12 epochs across seeds, and loss decreases monotonically with no divergence.">    </p:cNvPr>
           <p:cNvPicPr>
             <a:picLocks noChangeAspect="1"/>
           </p:cNvPicPr>
@@ -6080,7 +6024,7 @@
                 <a:ea typeface="Calibri" pitchFamily="34" charset="-122"/>
                 <a:cs typeface="Calibri" pitchFamily="34" charset="-120"/>
               </a:rPr>
-              <a:t>Fig. 5  v58 co-attention learning curves — train AUC + loss, 2 seeds, 12 epochs. Clean, no instability.</a:t>
+              <a:t>Fig. 5  v47 learning curves — per-cell train AUC + loss across seeds, 12 epochs. SWA over the last epochs.</a:t>
             </a:r>
             <a:endParaRPr lang="en-US" sz="900" dirty="0"/>
           </a:p>
@@ -6088,52 +6032,61 @@
       </p:sp>
       <p:sp>
         <p:nvSpPr>
-          <p:cNvPr id="8" name="Shape 5"/>
+          <p:cNvPr id="8" name="Text 5"/>
           <p:cNvSpPr/>
           <p:nvPr/>
         </p:nvSpPr>
         <p:spPr>
           <a:xfrm>
             <a:off x="5303520" y="1554480"/>
-            <a:ext cx="3566160" cy="822960"/>
+            <a:ext cx="3566160" cy="256032"/>
+          </a:xfrm>
+          <a:prstGeom prst="rect">
+            <a:avLst/>
+          </a:prstGeom>
+          <a:noFill/>
+          <a:ln/>
+        </p:spPr>
+        <p:txBody>
+          <a:bodyPr wrap="square" lIns="0" tIns="0" rIns="0" bIns="0" rtlCol="0" anchor="ctr"/>
+          <a:lstStyle/>
+          <a:p>
+            <a:pPr indent="0" marL="0">
+              <a:buNone/>
+            </a:pPr>
+            <a:r>
+              <a:rPr lang="en-US" sz="1050" b="1" spc="300" kern="0" dirty="0">
+                <a:solidFill>
+                  <a:srgbClr val="0D9488"/>
+                </a:solidFill>
+                <a:latin typeface="Calibri" pitchFamily="34" charset="0"/>
+                <a:ea typeface="Calibri" pitchFamily="34" charset="-122"/>
+                <a:cs typeface="Calibri" pitchFamily="34" charset="-120"/>
+              </a:rPr>
+              <a:t>What the curves show</a:t>
+            </a:r>
+            <a:endParaRPr lang="en-US" sz="1050" dirty="0"/>
+          </a:p>
+        </p:txBody>
+      </p:sp>
+      <p:sp>
+        <p:nvSpPr>
+          <p:cNvPr id="9" name="Shape 6"/>
+          <p:cNvSpPr/>
+          <p:nvPr/>
+        </p:nvSpPr>
+        <p:spPr>
+          <a:xfrm>
+            <a:off x="5303520" y="1847088"/>
+            <a:ext cx="36576" cy="2697480"/>
           </a:xfrm>
           <a:prstGeom prst="rect">
             <a:avLst/>
           </a:prstGeom>
           <a:solidFill>
-            <a:srgbClr val="FFFFFF"/>
-          </a:solidFill>
-          <a:ln w="6350">
-            <a:solidFill>
-              <a:srgbClr val="E5E7EB"/>
-            </a:solidFill>
-            <a:prstDash val="solid"/>
-          </a:ln>
-          <a:effectLst>
-            <a:outerShdw sx="100000" sy="100000" kx="0" ky="0" algn="bl" rotWithShape="0" blurRad="63500" dist="19050" dir="5400000">
-              <a:srgbClr val="000000">
-                <a:alpha val="6000"/>
-              </a:srgbClr>
-            </a:outerShdw>
-          </a:effectLst>
-        </p:spPr>
-      </p:sp>
-      <p:sp>
-        <p:nvSpPr>
-          <p:cNvPr id="9" name="Shape 6"/>
-          <p:cNvSpPr/>
-          <p:nvPr/>
-        </p:nvSpPr>
-        <p:spPr>
-          <a:xfrm>
-            <a:off x="5303520" y="1554480"/>
-            <a:ext cx="64008" cy="822960"/>
-          </a:xfrm>
-          <a:prstGeom prst="rect">
-            <a:avLst/>
-          </a:prstGeom>
-          <a:solidFill>
-            <a:srgbClr val="0D9488"/>
+            <a:srgbClr val="0D9488">
+              <a:alpha val="70000"/>
+            </a:srgbClr>
           </a:solidFill>
           <a:ln w="12700">
             <a:solidFill>
@@ -6151,8 +6104,8 @@
         </p:nvSpPr>
         <p:spPr>
           <a:xfrm>
-            <a:off x="5486400" y="1645920"/>
-            <a:ext cx="3291840" cy="452628"/>
+            <a:off x="5468112" y="1865376"/>
+            <a:ext cx="3364992" cy="2697480"/>
           </a:xfrm>
           <a:prstGeom prst="rect">
             <a:avLst/>
@@ -6164,375 +6117,280 @@
           <a:bodyPr wrap="square" lIns="0" tIns="0" rIns="0" bIns="0" rtlCol="0" anchor="t"/>
           <a:lstStyle/>
           <a:p>
-            <a:pPr algn="l" indent="0" marL="0">
-              <a:buNone/>
-            </a:pPr>
-            <a:r>
-              <a:rPr lang="en-US" sz="2100" b="1" dirty="0">
+            <a:pPr indent="0" marL="0">
+              <a:spcAft>
+                <a:spcPts val="600"/>
+              </a:spcAft>
+              <a:buNone/>
+            </a:pPr>
+            <a:r>
+              <a:rPr lang="en-US" sz="1000" b="1" dirty="0">
                 <a:solidFill>
                   <a:srgbClr val="0D9488"/>
                 </a:solidFill>
-                <a:latin typeface="Georgia" pitchFamily="34" charset="0"/>
-                <a:ea typeface="Georgia" pitchFamily="34" charset="-122"/>
-                <a:cs typeface="Georgia" pitchFamily="34" charset="-120"/>
-              </a:rPr>
-              <a:t>0.8392  ✓</a:t>
-            </a:r>
-            <a:endParaRPr lang="en-US" sz="2100" dirty="0"/>
+                <a:latin typeface="Calibri" pitchFamily="34" charset="0"/>
+                <a:ea typeface="Calibri" pitchFamily="34" charset="-122"/>
+                <a:cs typeface="Calibri" pitchFamily="34" charset="-120"/>
+              </a:rPr>
+              <a:t>— </a:t>
+            </a:r>
+            <a:pPr indent="0" marL="0">
+              <a:spcAft>
+                <a:spcPts val="600"/>
+              </a:spcAft>
+              <a:buNone/>
+            </a:pPr>
+            <a:r>
+              <a:rPr lang="en-US" sz="1000" b="1" dirty="0">
+                <a:solidFill>
+                  <a:srgbClr val="334155"/>
+                </a:solidFill>
+                <a:latin typeface="Calibri" pitchFamily="34" charset="0"/>
+                <a:ea typeface="Calibri" pitchFamily="34" charset="-122"/>
+                <a:cs typeface="Calibri" pitchFamily="34" charset="-120"/>
+              </a:rPr>
+              <a:t>Smooth convergence</a:t>
+            </a:r>
+            <a:pPr indent="0" marL="0">
+              <a:spcAft>
+                <a:spcPts val="600"/>
+              </a:spcAft>
+              <a:buNone/>
+            </a:pPr>
+            <a:r>
+              <a:rPr lang="en-US" sz="900" i="1" dirty="0">
+                <a:solidFill>
+                  <a:srgbClr val="64748B"/>
+                </a:solidFill>
+                <a:latin typeface="Calibri" pitchFamily="34" charset="0"/>
+                <a:ea typeface="Calibri" pitchFamily="34" charset="-122"/>
+                <a:cs typeface="Calibri" pitchFamily="34" charset="-120"/>
+              </a:rPr>
+              <a:t>  train AUC rises to ~0.99; loss falls monotonically, no divergence</a:t>
+            </a:r>
+            <a:endParaRPr lang="en-US" sz="1000" dirty="0"/>
+          </a:p>
+          <a:p>
+            <a:pPr indent="0" marL="0">
+              <a:spcAft>
+                <a:spcPts val="600"/>
+              </a:spcAft>
+              <a:buNone/>
+            </a:pPr>
+            <a:r>
+              <a:rPr lang="en-US" sz="1000" b="1" dirty="0">
+                <a:solidFill>
+                  <a:srgbClr val="0D9488"/>
+                </a:solidFill>
+                <a:latin typeface="Calibri" pitchFamily="34" charset="0"/>
+                <a:ea typeface="Calibri" pitchFamily="34" charset="-122"/>
+                <a:cs typeface="Calibri" pitchFamily="34" charset="-120"/>
+              </a:rPr>
+              <a:t>— </a:t>
+            </a:r>
+            <a:pPr indent="0" marL="0">
+              <a:spcAft>
+                <a:spcPts val="600"/>
+              </a:spcAft>
+              <a:buNone/>
+            </a:pPr>
+            <a:r>
+              <a:rPr lang="en-US" sz="1000" b="1" dirty="0">
+                <a:solidFill>
+                  <a:srgbClr val="334155"/>
+                </a:solidFill>
+                <a:latin typeface="Calibri" pitchFamily="34" charset="0"/>
+                <a:ea typeface="Calibri" pitchFamily="34" charset="-122"/>
+                <a:cs typeface="Calibri" pitchFamily="34" charset="-120"/>
+              </a:rPr>
+              <a:t>12 epochs</a:t>
+            </a:r>
+            <a:pPr indent="0" marL="0">
+              <a:spcAft>
+                <a:spcPts val="600"/>
+              </a:spcAft>
+              <a:buNone/>
+            </a:pPr>
+            <a:r>
+              <a:rPr lang="en-US" sz="900" i="1" dirty="0">
+                <a:solidFill>
+                  <a:srgbClr val="64748B"/>
+                </a:solidFill>
+                <a:latin typeface="Calibri" pitchFamily="34" charset="0"/>
+                <a:ea typeface="Calibri" pitchFamily="34" charset="-122"/>
+                <a:cs typeface="Calibri" pitchFamily="34" charset="-120"/>
+              </a:rPr>
+              <a:t>  AdamW + OneCycleLR, batch 128, gradient clipping</a:t>
+            </a:r>
+            <a:endParaRPr lang="en-US" sz="1000" dirty="0"/>
+          </a:p>
+          <a:p>
+            <a:pPr indent="0" marL="0">
+              <a:spcAft>
+                <a:spcPts val="600"/>
+              </a:spcAft>
+              <a:buNone/>
+            </a:pPr>
+            <a:r>
+              <a:rPr lang="en-US" sz="1000" b="1" dirty="0">
+                <a:solidFill>
+                  <a:srgbClr val="0D9488"/>
+                </a:solidFill>
+                <a:latin typeface="Calibri" pitchFamily="34" charset="0"/>
+                <a:ea typeface="Calibri" pitchFamily="34" charset="-122"/>
+                <a:cs typeface="Calibri" pitchFamily="34" charset="-120"/>
+              </a:rPr>
+              <a:t>— </a:t>
+            </a:r>
+            <a:pPr indent="0" marL="0">
+              <a:spcAft>
+                <a:spcPts val="600"/>
+              </a:spcAft>
+              <a:buNone/>
+            </a:pPr>
+            <a:r>
+              <a:rPr lang="en-US" sz="1000" b="1" dirty="0">
+                <a:solidFill>
+                  <a:srgbClr val="334155"/>
+                </a:solidFill>
+                <a:latin typeface="Calibri" pitchFamily="34" charset="0"/>
+                <a:ea typeface="Calibri" pitchFamily="34" charset="-122"/>
+                <a:cs typeface="Calibri" pitchFamily="34" charset="-120"/>
+              </a:rPr>
+              <a:t>SWA (Izmailov 2018)</a:t>
+            </a:r>
+            <a:pPr indent="0" marL="0">
+              <a:spcAft>
+                <a:spcPts val="600"/>
+              </a:spcAft>
+              <a:buNone/>
+            </a:pPr>
+            <a:r>
+              <a:rPr lang="en-US" sz="900" i="1" dirty="0">
+                <a:solidFill>
+                  <a:srgbClr val="64748B"/>
+                </a:solidFill>
+                <a:latin typeface="Calibri" pitchFamily="34" charset="0"/>
+                <a:ea typeface="Calibri" pitchFamily="34" charset="-122"/>
+                <a:cs typeface="Calibri" pitchFamily="34" charset="-120"/>
+              </a:rPr>
+              <a:t>  weights averaged over the last epochs + a manual BN refresh</a:t>
+            </a:r>
+            <a:endParaRPr lang="en-US" sz="1000" dirty="0"/>
+          </a:p>
+          <a:p>
+            <a:pPr indent="0" marL="0">
+              <a:spcAft>
+                <a:spcPts val="600"/>
+              </a:spcAft>
+              <a:buNone/>
+            </a:pPr>
+            <a:r>
+              <a:rPr lang="en-US" sz="1000" b="1" dirty="0">
+                <a:solidFill>
+                  <a:srgbClr val="0D9488"/>
+                </a:solidFill>
+                <a:latin typeface="Calibri" pitchFamily="34" charset="0"/>
+                <a:ea typeface="Calibri" pitchFamily="34" charset="-122"/>
+                <a:cs typeface="Calibri" pitchFamily="34" charset="-120"/>
+              </a:rPr>
+              <a:t>— </a:t>
+            </a:r>
+            <a:pPr indent="0" marL="0">
+              <a:spcAft>
+                <a:spcPts val="600"/>
+              </a:spcAft>
+              <a:buNone/>
+            </a:pPr>
+            <a:r>
+              <a:rPr lang="en-US" sz="1000" b="1" dirty="0">
+                <a:solidFill>
+                  <a:srgbClr val="334155"/>
+                </a:solidFill>
+                <a:latin typeface="Calibri" pitchFamily="34" charset="0"/>
+                <a:ea typeface="Calibri" pitchFamily="34" charset="-122"/>
+                <a:cs typeface="Calibri" pitchFamily="34" charset="-120"/>
+              </a:rPr>
+              <a:t>Per-patient MIL aux</a:t>
+            </a:r>
+            <a:pPr indent="0" marL="0">
+              <a:spcAft>
+                <a:spcPts val="600"/>
+              </a:spcAft>
+              <a:buNone/>
+            </a:pPr>
+            <a:r>
+              <a:rPr lang="en-US" sz="900" i="1" dirty="0">
+                <a:solidFill>
+                  <a:srgbClr val="64748B"/>
+                </a:solidFill>
+                <a:latin typeface="Calibri" pitchFamily="34" charset="0"/>
+                <a:ea typeface="Calibri" pitchFamily="34" charset="-122"/>
+                <a:cs typeface="Calibri" pitchFamily="34" charset="-120"/>
+              </a:rPr>
+              <a:t>  regularises against within-patient memorisation</a:t>
+            </a:r>
+            <a:endParaRPr lang="en-US" sz="1000" dirty="0"/>
+          </a:p>
+          <a:p>
+            <a:pPr indent="0" marL="0">
+              <a:spcAft>
+                <a:spcPts val="600"/>
+              </a:spcAft>
+              <a:buNone/>
+            </a:pPr>
+            <a:r>
+              <a:rPr lang="en-US" sz="1000" b="1" dirty="0">
+                <a:solidFill>
+                  <a:srgbClr val="0D9488"/>
+                </a:solidFill>
+                <a:latin typeface="Calibri" pitchFamily="34" charset="0"/>
+                <a:ea typeface="Calibri" pitchFamily="34" charset="-122"/>
+                <a:cs typeface="Calibri" pitchFamily="34" charset="-120"/>
+              </a:rPr>
+              <a:t>— </a:t>
+            </a:r>
+            <a:pPr indent="0" marL="0">
+              <a:spcAft>
+                <a:spcPts val="600"/>
+              </a:spcAft>
+              <a:buNone/>
+            </a:pPr>
+            <a:r>
+              <a:rPr lang="en-US" sz="1000" b="1" dirty="0">
+                <a:solidFill>
+                  <a:srgbClr val="334155"/>
+                </a:solidFill>
+                <a:latin typeface="Calibri" pitchFamily="34" charset="0"/>
+                <a:ea typeface="Calibri" pitchFamily="34" charset="-122"/>
+                <a:cs typeface="Calibri" pitchFamily="34" charset="-120"/>
+              </a:rPr>
+              <a:t>No held-out val</a:t>
+            </a:r>
+            <a:pPr indent="0" marL="0">
+              <a:spcAft>
+                <a:spcPts val="600"/>
+              </a:spcAft>
+              <a:buNone/>
+            </a:pPr>
+            <a:r>
+              <a:rPr lang="en-US" sz="900" i="1" dirty="0">
+                <a:solidFill>
+                  <a:srgbClr val="64748B"/>
+                </a:solidFill>
+                <a:latin typeface="Calibri" pitchFamily="34" charset="0"/>
+                <a:ea typeface="Calibri" pitchFamily="34" charset="-122"/>
+                <a:cs typeface="Calibri" pitchFamily="34" charset="-120"/>
+              </a:rPr>
+              <a:t>  N=12 is too small; the public LB is the external check</a:t>
+            </a:r>
+            <a:endParaRPr lang="en-US" sz="1000" dirty="0"/>
           </a:p>
         </p:txBody>
       </p:sp>
       <p:sp>
         <p:nvSpPr>
           <p:cNvPr id="11" name="Text 8"/>
-          <p:cNvSpPr/>
-          <p:nvPr/>
-        </p:nvSpPr>
-        <p:spPr>
-          <a:xfrm>
-            <a:off x="5486400" y="2007108"/>
-            <a:ext cx="3291840" cy="370332"/>
-          </a:xfrm>
-          <a:prstGeom prst="rect">
-            <a:avLst/>
-          </a:prstGeom>
-          <a:noFill/>
-          <a:ln/>
-        </p:spPr>
-        <p:txBody>
-          <a:bodyPr wrap="square" lIns="0" tIns="0" rIns="0" bIns="0" rtlCol="0" anchor="t"/>
-          <a:lstStyle/>
-          <a:p>
-            <a:pPr algn="l" indent="0" marL="0">
-              <a:buNone/>
-            </a:pPr>
-            <a:r>
-              <a:rPr lang="en-US" sz="900" dirty="0">
-                <a:solidFill>
-                  <a:srgbClr val="64748B"/>
-                </a:solidFill>
-                <a:latin typeface="Calibri" pitchFamily="34" charset="0"/>
-                <a:ea typeface="Calibri" pitchFamily="34" charset="-122"/>
-                <a:cs typeface="Calibri" pitchFamily="34" charset="-120"/>
-              </a:rPr>
-              <a:t>intermediate CO-ATTENTION (CAFNet-style) — new best, beats v47's 0.8355</a:t>
-            </a:r>
-            <a:endParaRPr lang="en-US" sz="900" dirty="0"/>
-          </a:p>
-        </p:txBody>
-      </p:sp>
-      <p:sp>
-        <p:nvSpPr>
-          <p:cNvPr id="12" name="Shape 9"/>
-          <p:cNvSpPr/>
-          <p:nvPr/>
-        </p:nvSpPr>
-        <p:spPr>
-          <a:xfrm>
-            <a:off x="5303520" y="2468880"/>
-            <a:ext cx="3566160" cy="822960"/>
-          </a:xfrm>
-          <a:prstGeom prst="rect">
-            <a:avLst/>
-          </a:prstGeom>
-          <a:solidFill>
-            <a:srgbClr val="FFFFFF"/>
-          </a:solidFill>
-          <a:ln w="6350">
-            <a:solidFill>
-              <a:srgbClr val="E5E7EB"/>
-            </a:solidFill>
-            <a:prstDash val="solid"/>
-          </a:ln>
-          <a:effectLst>
-            <a:outerShdw sx="100000" sy="100000" kx="0" ky="0" algn="bl" rotWithShape="0" blurRad="63500" dist="19050" dir="5400000">
-              <a:srgbClr val="000000">
-                <a:alpha val="6000"/>
-              </a:srgbClr>
-            </a:outerShdw>
-          </a:effectLst>
-        </p:spPr>
-      </p:sp>
-      <p:sp>
-        <p:nvSpPr>
-          <p:cNvPr id="13" name="Shape 10"/>
-          <p:cNvSpPr/>
-          <p:nvPr/>
-        </p:nvSpPr>
-        <p:spPr>
-          <a:xfrm>
-            <a:off x="5303520" y="2468880"/>
-            <a:ext cx="64008" cy="822960"/>
-          </a:xfrm>
-          <a:prstGeom prst="rect">
-            <a:avLst/>
-          </a:prstGeom>
-          <a:solidFill>
-            <a:srgbClr val="B91C1C"/>
-          </a:solidFill>
-          <a:ln w="12700">
-            <a:solidFill>
-              <a:srgbClr val="B91C1C"/>
-            </a:solidFill>
-            <a:prstDash val="solid"/>
-          </a:ln>
-        </p:spPr>
-      </p:sp>
-      <p:sp>
-        <p:nvSpPr>
-          <p:cNvPr id="14" name="Text 11"/>
-          <p:cNvSpPr/>
-          <p:nvPr/>
-        </p:nvSpPr>
-        <p:spPr>
-          <a:xfrm>
-            <a:off x="5486400" y="2560320"/>
-            <a:ext cx="3291840" cy="452628"/>
-          </a:xfrm>
-          <a:prstGeom prst="rect">
-            <a:avLst/>
-          </a:prstGeom>
-          <a:noFill/>
-          <a:ln/>
-        </p:spPr>
-        <p:txBody>
-          <a:bodyPr wrap="square" lIns="0" tIns="0" rIns="0" bIns="0" rtlCol="0" anchor="t"/>
-          <a:lstStyle/>
-          <a:p>
-            <a:pPr algn="l" indent="0" marL="0">
-              <a:buNone/>
-            </a:pPr>
-            <a:r>
-              <a:rPr lang="en-US" sz="2100" b="1" dirty="0">
-                <a:solidFill>
-                  <a:srgbClr val="B91C1C"/>
-                </a:solidFill>
-                <a:latin typeface="Georgia" pitchFamily="34" charset="0"/>
-                <a:ea typeface="Georgia" pitchFamily="34" charset="-122"/>
-                <a:cs typeface="Georgia" pitchFamily="34" charset="-120"/>
-              </a:rPr>
-              <a:t>0.7823  ✗</a:t>
-            </a:r>
-            <a:endParaRPr lang="en-US" sz="2100" dirty="0"/>
-          </a:p>
-        </p:txBody>
-      </p:sp>
-      <p:sp>
-        <p:nvSpPr>
-          <p:cNvPr id="15" name="Text 12"/>
-          <p:cNvSpPr/>
-          <p:nvPr/>
-        </p:nvSpPr>
-        <p:spPr>
-          <a:xfrm>
-            <a:off x="5486400" y="2921508"/>
-            <a:ext cx="3291840" cy="370332"/>
-          </a:xfrm>
-          <a:prstGeom prst="rect">
-            <a:avLst/>
-          </a:prstGeom>
-          <a:noFill/>
-          <a:ln/>
-        </p:spPr>
-        <p:txBody>
-          <a:bodyPr wrap="square" lIns="0" tIns="0" rIns="0" bIns="0" rtlCol="0" anchor="t"/>
-          <a:lstStyle/>
-          <a:p>
-            <a:pPr algn="l" indent="0" marL="0">
-              <a:buNone/>
-            </a:pPr>
-            <a:r>
-              <a:rPr lang="en-US" sz="900" dirty="0">
-                <a:solidFill>
-                  <a:srgbClr val="64748B"/>
-                </a:solidFill>
-                <a:latin typeface="Calibri" pitchFamily="34" charset="0"/>
-                <a:ea typeface="Calibri" pitchFamily="34" charset="-122"/>
-                <a:cs typeface="Calibri" pitchFamily="34" charset="-120"/>
-              </a:rPr>
-              <a:t>higher resolution (192 px) — regressed</a:t>
-            </a:r>
-            <a:endParaRPr lang="en-US" sz="900" dirty="0"/>
-          </a:p>
-        </p:txBody>
-      </p:sp>
-      <p:sp>
-        <p:nvSpPr>
-          <p:cNvPr id="16" name="Shape 13"/>
-          <p:cNvSpPr/>
-          <p:nvPr/>
-        </p:nvSpPr>
-        <p:spPr>
-          <a:xfrm>
-            <a:off x="5303520" y="3383280"/>
-            <a:ext cx="3566160" cy="822960"/>
-          </a:xfrm>
-          <a:prstGeom prst="rect">
-            <a:avLst/>
-          </a:prstGeom>
-          <a:solidFill>
-            <a:srgbClr val="FFFFFF"/>
-          </a:solidFill>
-          <a:ln w="6350">
-            <a:solidFill>
-              <a:srgbClr val="E5E7EB"/>
-            </a:solidFill>
-            <a:prstDash val="solid"/>
-          </a:ln>
-          <a:effectLst>
-            <a:outerShdw sx="100000" sy="100000" kx="0" ky="0" algn="bl" rotWithShape="0" blurRad="63500" dist="19050" dir="5400000">
-              <a:srgbClr val="000000">
-                <a:alpha val="6000"/>
-              </a:srgbClr>
-            </a:outerShdw>
-          </a:effectLst>
-        </p:spPr>
-      </p:sp>
-      <p:sp>
-        <p:nvSpPr>
-          <p:cNvPr id="17" name="Shape 14"/>
-          <p:cNvSpPr/>
-          <p:nvPr/>
-        </p:nvSpPr>
-        <p:spPr>
-          <a:xfrm>
-            <a:off x="5303520" y="3383280"/>
-            <a:ext cx="64008" cy="822960"/>
-          </a:xfrm>
-          <a:prstGeom prst="rect">
-            <a:avLst/>
-          </a:prstGeom>
-          <a:solidFill>
-            <a:srgbClr val="B91C1C"/>
-          </a:solidFill>
-          <a:ln w="12700">
-            <a:solidFill>
-              <a:srgbClr val="B91C1C"/>
-            </a:solidFill>
-            <a:prstDash val="solid"/>
-          </a:ln>
-        </p:spPr>
-      </p:sp>
-      <p:sp>
-        <p:nvSpPr>
-          <p:cNvPr id="18" name="Text 15"/>
-          <p:cNvSpPr/>
-          <p:nvPr/>
-        </p:nvSpPr>
-        <p:spPr>
-          <a:xfrm>
-            <a:off x="5486400" y="3474720"/>
-            <a:ext cx="3291840" cy="452628"/>
-          </a:xfrm>
-          <a:prstGeom prst="rect">
-            <a:avLst/>
-          </a:prstGeom>
-          <a:noFill/>
-          <a:ln/>
-        </p:spPr>
-        <p:txBody>
-          <a:bodyPr wrap="square" lIns="0" tIns="0" rIns="0" bIns="0" rtlCol="0" anchor="t"/>
-          <a:lstStyle/>
-          <a:p>
-            <a:pPr algn="l" indent="0" marL="0">
-              <a:buNone/>
-            </a:pPr>
-            <a:r>
-              <a:rPr lang="en-US" sz="2100" b="1" dirty="0">
-                <a:solidFill>
-                  <a:srgbClr val="B91C1C"/>
-                </a:solidFill>
-                <a:latin typeface="Georgia" pitchFamily="34" charset="0"/>
-                <a:ea typeface="Georgia" pitchFamily="34" charset="-122"/>
-                <a:cs typeface="Georgia" pitchFamily="34" charset="-120"/>
-              </a:rPr>
-              <a:t>0.7376  ✗</a:t>
-            </a:r>
-            <a:endParaRPr lang="en-US" sz="2100" dirty="0"/>
-          </a:p>
-        </p:txBody>
-      </p:sp>
-      <p:sp>
-        <p:nvSpPr>
-          <p:cNvPr id="19" name="Text 16"/>
-          <p:cNvSpPr/>
-          <p:nvPr/>
-        </p:nvSpPr>
-        <p:spPr>
-          <a:xfrm>
-            <a:off x="5486400" y="3835908"/>
-            <a:ext cx="3291840" cy="370332"/>
-          </a:xfrm>
-          <a:prstGeom prst="rect">
-            <a:avLst/>
-          </a:prstGeom>
-          <a:noFill/>
-          <a:ln/>
-        </p:spPr>
-        <p:txBody>
-          <a:bodyPr wrap="square" lIns="0" tIns="0" rIns="0" bIns="0" rtlCol="0" anchor="t"/>
-          <a:lstStyle/>
-          <a:p>
-            <a:pPr algn="l" indent="0" marL="0">
-              <a:buNone/>
-            </a:pPr>
-            <a:r>
-              <a:rPr lang="en-US" sz="900" dirty="0">
-                <a:solidFill>
-                  <a:srgbClr val="64748B"/>
-                </a:solidFill>
-                <a:latin typeface="Calibri" pitchFamily="34" charset="0"/>
-                <a:ea typeface="Calibri" pitchFamily="34" charset="-122"/>
-                <a:cs typeface="Calibri" pitchFamily="34" charset="-120"/>
-              </a:rPr>
-              <a:t>more capacity (EfficientNetV2-S) — regressed</a:t>
-            </a:r>
-            <a:endParaRPr lang="en-US" sz="900" dirty="0"/>
-          </a:p>
-        </p:txBody>
-      </p:sp>
-      <p:sp>
-        <p:nvSpPr>
-          <p:cNvPr id="20" name="Text 17"/>
-          <p:cNvSpPr/>
-          <p:nvPr/>
-        </p:nvSpPr>
-        <p:spPr>
-          <a:xfrm>
-            <a:off x="5303520" y="4334256"/>
-            <a:ext cx="3566160" cy="502920"/>
-          </a:xfrm>
-          <a:prstGeom prst="rect">
-            <a:avLst/>
-          </a:prstGeom>
-          <a:noFill/>
-          <a:ln/>
-        </p:spPr>
-        <p:txBody>
-          <a:bodyPr wrap="square" lIns="0" tIns="0" rIns="0" bIns="0" rtlCol="0" anchor="ctr"/>
-          <a:lstStyle/>
-          <a:p>
-            <a:pPr indent="0" marL="0">
-              <a:buNone/>
-            </a:pPr>
-            <a:r>
-              <a:rPr lang="en-US" sz="950" i="1" dirty="0">
-                <a:solidFill>
-                  <a:srgbClr val="334155"/>
-                </a:solidFill>
-                <a:latin typeface="Calibri" pitchFamily="34" charset="0"/>
-                <a:ea typeface="Calibri" pitchFamily="34" charset="-122"/>
-                <a:cs typeface="Calibri" pitchFamily="34" charset="-120"/>
-              </a:rPr>
-              <a:t>Of every architecture tried, only fusion design moved the needle — the model is data-bound. Capacity and resolution both hurt.</a:t>
-            </a:r>
-            <a:endParaRPr lang="en-US" sz="950" dirty="0"/>
-          </a:p>
-        </p:txBody>
-      </p:sp>
-      <p:sp>
-        <p:nvSpPr>
-          <p:cNvPr id="21" name="Text 18"/>
           <p:cNvSpPr/>
           <p:nvPr/>
         </p:nvSpPr>
@@ -6571,7 +6429,7 @@
       </p:sp>
       <p:sp>
         <p:nvSpPr>
-          <p:cNvPr id="22" name="Text 19"/>
+          <p:cNvPr id="12" name="Text 9"/>
           <p:cNvSpPr/>
           <p:nvPr/>
         </p:nvSpPr>
@@ -7244,7 +7102,7 @@
                 <a:ea typeface="Calibri" pitchFamily="34" charset="-122"/>
                 <a:cs typeface="Calibri" pitchFamily="34" charset="-120"/>
               </a:rPr>
-              <a:t>Four regularisers gained +0.011; soft-pseudo distillation gained +0.042. Even the SOTA co-attention fusion ≈ plain late fusion (0.97 corr, both 0.83). Only co-attention fusion nudged architecture (+0.004 to a new best 0.8392); data was ~10x bigger.</a:t>
+              <a:t>Four regularisers gained +0.011; soft-pseudo distillation gained +0.042 — about 4× more lift from growing the effective dataset than from any architecture or regulariser change.</a:t>
             </a:r>
             <a:endParaRPr lang="en-US" sz="1050" dirty="0"/>
           </a:p>
@@ -8155,7 +8013,7 @@
                 <a:ea typeface="Georgia" pitchFamily="34" charset="-122"/>
                 <a:cs typeface="Georgia" pitchFamily="34" charset="-120"/>
               </a:rPr>
-              <a:t>0.8392</a:t>
+              <a:t>0.8355</a:t>
             </a:r>
             <a:endParaRPr lang="en-US" sz="2400" dirty="0"/>
           </a:p>
@@ -8194,7 +8052,7 @@
                 <a:ea typeface="Calibri" pitchFamily="34" charset="-122"/>
                 <a:cs typeface="Calibri" pitchFamily="34" charset="-120"/>
               </a:rPr>
-              <a:t>BEST LB  ·  v58 co-attention</a:t>
+              <a:t>BEST LB  ·  v47 distillation</a:t>
             </a:r>
             <a:endParaRPr lang="en-US" sz="950" dirty="0"/>
           </a:p>
@@ -10754,7 +10612,7 @@
                 <a:ea typeface="Georgia" pitchFamily="34" charset="-122"/>
                 <a:cs typeface="Georgia" pitchFamily="34" charset="-120"/>
               </a:rPr>
-              <a:t>+0.094 LB total — the biggest single jump (+0.039) was soft-pseudo distillation (Hinton 2015).</a:t>
+              <a:t>+0.081 LB total — the biggest single jump (+0.039) was soft-pseudo distillation (Hinton 2015).</a:t>
             </a:r>
             <a:endParaRPr lang="en-US" sz="950" dirty="0"/>
           </a:p>

</xml_diff>